<commit_message>
Build 19-slide Putnam YouTube presentation
</commit_message>
<xml_diff>
--- a/Presentation/Putnam_Fact_Value_Entanglement_YouTube_Deck.pptx
+++ b/Presentation/Putnam_Fact_Value_Entanglement_YouTube_Deck.pptx
@@ -2606,8 +2606,8 @@
         </p:nvSpPr>
         <p:spPr>
           <a:xfrm>
-            <a:off x="7406640" y="1051560"/>
-            <a:ext cx="3474720" cy="786384"/>
+            <a:off x="7452360" y="914400"/>
+            <a:ext cx="3337560" cy="694944"/>
           </a:xfrm>
           <a:prstGeom prst="rect">
             <a:avLst/>
@@ -2631,14 +2631,14 @@
               <a:buNone/>
             </a:pPr>
             <a:r>
-              <a:rPr lang="en-US" sz="2300" b="1" dirty="0">
+              <a:rPr lang="en-US" sz="2200" b="1" dirty="0">
                 <a:solidFill>
                   <a:srgbClr val="FFFFFF"/>
                 </a:solidFill>
               </a:rPr>
               <a:t>FACTS</a:t>
             </a:r>
-            <a:endParaRPr lang="en-US" sz="2300" dirty="0"/>
+            <a:endParaRPr lang="en-US" sz="2200" dirty="0"/>
           </a:p>
         </p:txBody>
       </p:sp>
@@ -2650,8 +2650,8 @@
         </p:nvSpPr>
         <p:spPr>
           <a:xfrm>
-            <a:off x="7360920" y="1965960"/>
-            <a:ext cx="3657600" cy="411480"/>
+            <a:off x="7360920" y="1737360"/>
+            <a:ext cx="3657600" cy="347472"/>
           </a:xfrm>
           <a:prstGeom prst="rect">
             <a:avLst/>
@@ -2688,8 +2688,8 @@
         </p:nvSpPr>
         <p:spPr>
           <a:xfrm>
-            <a:off x="8595360" y="2487168"/>
-            <a:ext cx="1188720" cy="502920"/>
+            <a:off x="8549640" y="2148840"/>
+            <a:ext cx="1188720" cy="438912"/>
           </a:xfrm>
           <a:prstGeom prst="rect">
             <a:avLst/>
@@ -2705,14 +2705,14 @@
               <a:buNone/>
             </a:pPr>
             <a:r>
-              <a:rPr lang="en-US" sz="3000" b="1" dirty="0">
+              <a:rPr lang="en-US" sz="2800" b="1" dirty="0">
                 <a:solidFill>
                   <a:srgbClr val="FFFFFF"/>
                 </a:solidFill>
               </a:rPr>
               <a:t>↕</a:t>
             </a:r>
-            <a:endParaRPr lang="en-US" sz="3000" dirty="0"/>
+            <a:endParaRPr lang="en-US" sz="2800" dirty="0"/>
           </a:p>
         </p:txBody>
       </p:sp>
@@ -2724,8 +2724,8 @@
         </p:nvSpPr>
         <p:spPr>
           <a:xfrm>
-            <a:off x="7406640" y="3063240"/>
-            <a:ext cx="3474720" cy="786384"/>
+            <a:off x="7452360" y="2697480"/>
+            <a:ext cx="3337560" cy="694944"/>
           </a:xfrm>
           <a:prstGeom prst="rect">
             <a:avLst/>
@@ -2749,14 +2749,14 @@
               <a:buNone/>
             </a:pPr>
             <a:r>
-              <a:rPr lang="en-US" sz="2300" b="1" dirty="0">
+              <a:rPr lang="en-US" sz="2200" b="1" dirty="0">
                 <a:solidFill>
                   <a:srgbClr val="FFFFFF"/>
                 </a:solidFill>
               </a:rPr>
               <a:t>VALUES</a:t>
             </a:r>
-            <a:endParaRPr lang="en-US" sz="2300" dirty="0"/>
+            <a:endParaRPr lang="en-US" sz="2200" dirty="0"/>
           </a:p>
         </p:txBody>
       </p:sp>
@@ -2768,8 +2768,8 @@
         </p:nvSpPr>
         <p:spPr>
           <a:xfrm>
-            <a:off x="7360920" y="3977640"/>
-            <a:ext cx="3657600" cy="411480"/>
+            <a:off x="7360920" y="3520440"/>
+            <a:ext cx="3657600" cy="347472"/>
           </a:xfrm>
           <a:prstGeom prst="rect">
             <a:avLst/>
@@ -2806,8 +2806,8 @@
         </p:nvSpPr>
         <p:spPr>
           <a:xfrm>
-            <a:off x="749808" y="4937760"/>
-            <a:ext cx="6309360" cy="640080"/>
+            <a:off x="749808" y="4709160"/>
+            <a:ext cx="6126480" cy="822960"/>
           </a:xfrm>
           <a:prstGeom prst="rect">
             <a:avLst/>
@@ -2825,14 +2825,28 @@
               <a:buNone/>
             </a:pPr>
             <a:r>
-              <a:rPr lang="en-US" sz="2000" b="1" dirty="0">
+              <a:rPr lang="en-US" sz="1950" b="1" dirty="0">
                 <a:solidFill>
                   <a:srgbClr val="FFFFFF"/>
                 </a:solidFill>
               </a:rPr>
-              <a:t>The ordinary picture looks clean. Too clean.</a:t>
-            </a:r>
-            <a:endParaRPr lang="en-US" sz="2000" dirty="0"/>
+              <a:t>The ordinary picture looks clean.</a:t>
+            </a:r>
+            <a:endParaRPr lang="en-US" sz="1950" dirty="0"/>
+          </a:p>
+          <a:p>
+            <a:pPr indent="0" marL="0">
+              <a:buNone/>
+            </a:pPr>
+            <a:r>
+              <a:rPr lang="en-US" sz="1950" b="1" dirty="0">
+                <a:solidFill>
+                  <a:srgbClr val="FFFFFF"/>
+                </a:solidFill>
+              </a:rPr>
+              <a:t>Maybe too clean.</a:t>
+            </a:r>
+            <a:endParaRPr lang="en-US" sz="1950" dirty="0"/>
           </a:p>
         </p:txBody>
       </p:sp>
@@ -3100,7 +3114,7 @@
                   <a:srgbClr val="6B7A7C"/>
                 </a:solidFill>
               </a:rPr>
-              <a:t>The other extreme also exists.</a:t>
+              <a:t>The other extreme exists too.</a:t>
             </a:r>
             <a:endParaRPr lang="en-US" sz="1450" dirty="0"/>
           </a:p>
@@ -3114,8 +3128,8 @@
         </p:nvSpPr>
         <p:spPr>
           <a:xfrm>
-            <a:off x="1874520" y="5257800"/>
-            <a:ext cx="8138160" cy="0"/>
+            <a:off x="1280160" y="5321808"/>
+            <a:ext cx="9144000" cy="0"/>
           </a:xfrm>
           <a:prstGeom prst="line">
             <a:avLst/>
@@ -3139,8 +3153,8 @@
         </p:nvSpPr>
         <p:spPr>
           <a:xfrm>
-            <a:off x="1874520" y="5257800"/>
-            <a:ext cx="0" cy="-3154680"/>
+            <a:off x="1280160" y="5321808"/>
+            <a:ext cx="0" cy="-3401568"/>
           </a:xfrm>
           <a:prstGeom prst="line">
             <a:avLst/>
@@ -3164,8 +3178,8 @@
         </p:nvSpPr>
         <p:spPr>
           <a:xfrm>
-            <a:off x="9875520" y="5367528"/>
-            <a:ext cx="320040" cy="228600"/>
+            <a:off x="8823960" y="5468112"/>
+            <a:ext cx="1737360" cy="256032"/>
           </a:xfrm>
           <a:prstGeom prst="rect">
             <a:avLst/>
@@ -3183,14 +3197,14 @@
               <a:buNone/>
             </a:pPr>
             <a:r>
-              <a:rPr lang="en-US" sz="1500" b="1" dirty="0">
+              <a:rPr lang="en-US" sz="1200" b="1" dirty="0">
                 <a:solidFill>
                   <a:srgbClr val="6B7A7C"/>
                 </a:solidFill>
               </a:rPr>
-              <a:t>f</a:t>
-            </a:r>
-            <a:endParaRPr lang="en-US" sz="1500" dirty="0"/>
+              <a:t>descriptive content  f</a:t>
+            </a:r>
+            <a:endParaRPr lang="en-US" sz="1200" dirty="0"/>
           </a:p>
         </p:txBody>
       </p:sp>
@@ -3202,8 +3216,8 @@
         </p:nvSpPr>
         <p:spPr>
           <a:xfrm>
-            <a:off x="1554480" y="1938528"/>
-            <a:ext cx="274320" cy="228600"/>
+            <a:off x="868680" y="1700784"/>
+            <a:ext cx="1828800" cy="256032"/>
           </a:xfrm>
           <a:prstGeom prst="rect">
             <a:avLst/>
@@ -3217,18 +3231,18 @@
           </a:bodyPr>
           <a:lstStyle/>
           <a:p>
-            <a:pPr algn="ctr" indent="0" marL="0">
-              <a:buNone/>
-            </a:pPr>
-            <a:r>
-              <a:rPr lang="en-US" sz="1500" b="1" dirty="0">
+            <a:pPr algn="l" indent="0" marL="0">
+              <a:buNone/>
+            </a:pPr>
+            <a:r>
+              <a:rPr lang="en-US" sz="1200" b="1" dirty="0">
                 <a:solidFill>
                   <a:srgbClr val="6B7A7C"/>
                 </a:solidFill>
               </a:rPr>
-              <a:t>v</a:t>
-            </a:r>
-            <a:endParaRPr lang="en-US" sz="1500" dirty="0"/>
+              <a:t>evaluative content  v</a:t>
+            </a:r>
+            <a:endParaRPr lang="en-US" sz="1200" dirty="0"/>
           </a:p>
         </p:txBody>
       </p:sp>
@@ -3240,7 +3254,7 @@
         </p:nvSpPr>
         <p:spPr>
           <a:xfrm>
-            <a:off x="2532888" y="2350008"/>
+            <a:off x="2167128" y="2231136"/>
             <a:ext cx="329184" cy="329184"/>
           </a:xfrm>
           <a:prstGeom prst="ellipse">
@@ -3265,84 +3279,8 @@
         </p:nvSpPr>
         <p:spPr>
           <a:xfrm>
-            <a:off x="3063240" y="2212848"/>
-            <a:ext cx="2286000" cy="411480"/>
-          </a:xfrm>
-          <a:prstGeom prst="rect">
-            <a:avLst/>
-          </a:prstGeom>
-          <a:noFill/>
-          <a:ln/>
-        </p:spPr>
-        <p:txBody>
-          <a:bodyPr wrap="square" lIns="254" tIns="254" rIns="254" bIns="254" rtlCol="0" anchor="ctr">
-            <a:normAutofit/>
-          </a:bodyPr>
-          <a:lstStyle/>
-          <a:p>
-            <a:pPr algn="ctr" indent="0" marL="0">
-              <a:buNone/>
-            </a:pPr>
-            <a:r>
-              <a:rPr lang="en-US" sz="1800" b="1" dirty="0">
-                <a:solidFill>
-                  <a:srgbClr val="304245"/>
-                </a:solidFill>
-              </a:rPr>
-              <a:t>“admirable”</a:t>
-            </a:r>
-            <a:endParaRPr lang="en-US" sz="1800" dirty="0"/>
-          </a:p>
-        </p:txBody>
-      </p:sp>
-      <p:sp>
-        <p:nvSpPr>
-          <p:cNvPr id="14" name="Text 12"/>
-          <p:cNvSpPr/>
-          <p:nvPr/>
-        </p:nvSpPr>
-        <p:spPr>
-          <a:xfrm>
-            <a:off x="3063240" y="2743200"/>
-            <a:ext cx="2286000" cy="411480"/>
-          </a:xfrm>
-          <a:prstGeom prst="rect">
-            <a:avLst/>
-          </a:prstGeom>
-          <a:noFill/>
-          <a:ln/>
-        </p:spPr>
-        <p:txBody>
-          <a:bodyPr wrap="square" lIns="254" tIns="254" rIns="254" bIns="254" rtlCol="0" anchor="ctr">
-            <a:normAutofit/>
-          </a:bodyPr>
-          <a:lstStyle/>
-          <a:p>
-            <a:pPr algn="ctr" indent="0" marL="0">
-              <a:buNone/>
-            </a:pPr>
-            <a:r>
-              <a:rPr lang="en-US" sz="1600" dirty="0">
-                <a:solidFill>
-                  <a:srgbClr val="6B7A7C"/>
-                </a:solidFill>
-              </a:rPr>
-              <a:t>“disgusting”</a:t>
-            </a:r>
-            <a:endParaRPr lang="en-US" sz="1600" dirty="0"/>
-          </a:p>
-        </p:txBody>
-      </p:sp>
-      <p:sp>
-        <p:nvSpPr>
-          <p:cNvPr id="15" name="Text 13"/>
-          <p:cNvSpPr/>
-          <p:nvPr/>
-        </p:nvSpPr>
-        <p:spPr>
-          <a:xfrm>
-            <a:off x="6400800" y="2331720"/>
-            <a:ext cx="2926080" cy="749808"/>
+            <a:off x="7863840" y="1938528"/>
+            <a:ext cx="3017520" cy="658368"/>
           </a:xfrm>
           <a:prstGeom prst="rect">
             <a:avLst/>
@@ -3379,7 +3317,149 @@
       </p:sp>
       <p:sp>
         <p:nvSpPr>
+          <p:cNvPr id="14" name="Shape 12"/>
+          <p:cNvSpPr/>
+          <p:nvPr/>
+        </p:nvSpPr>
+        <p:spPr>
+          <a:xfrm>
+            <a:off x="2423160" y="2971800"/>
+            <a:ext cx="3246120" cy="1188720"/>
+          </a:xfrm>
+          <a:prstGeom prst="roundRect">
+            <a:avLst>
+              <a:gd name="adj" fmla="val 6154"/>
+            </a:avLst>
+          </a:prstGeom>
+          <a:solidFill>
+            <a:srgbClr val="FBF0E7"/>
+          </a:solidFill>
+          <a:ln w="13970">
+            <a:solidFill>
+              <a:srgbClr val="D8E2E0"/>
+            </a:solidFill>
+            <a:prstDash val="solid"/>
+          </a:ln>
+        </p:spPr>
+      </p:sp>
+      <p:sp>
+        <p:nvSpPr>
+          <p:cNvPr id="15" name="Shape 13"/>
+          <p:cNvSpPr/>
+          <p:nvPr/>
+        </p:nvSpPr>
+        <p:spPr>
+          <a:xfrm>
+            <a:off x="2423160" y="2971800"/>
+            <a:ext cx="73152" cy="1188720"/>
+          </a:xfrm>
+          <a:prstGeom prst="rect">
+            <a:avLst/>
+          </a:prstGeom>
+          <a:solidFill>
+            <a:srgbClr val="E58A3B"/>
+          </a:solidFill>
+          <a:ln w="12700">
+            <a:solidFill>
+              <a:srgbClr val="E58A3B"/>
+            </a:solidFill>
+            <a:prstDash val="solid"/>
+          </a:ln>
+        </p:spPr>
+      </p:sp>
+      <p:sp>
+        <p:nvSpPr>
           <p:cNvPr id="16" name="Text 14"/>
+          <p:cNvSpPr/>
+          <p:nvPr/>
+        </p:nvSpPr>
+        <p:spPr>
+          <a:xfrm>
+            <a:off x="2679192" y="3172968"/>
+            <a:ext cx="2788920" cy="329184"/>
+          </a:xfrm>
+          <a:prstGeom prst="rect">
+            <a:avLst/>
+          </a:prstGeom>
+          <a:noFill/>
+          <a:ln/>
+        </p:spPr>
+        <p:txBody>
+          <a:bodyPr wrap="square" lIns="0" tIns="0" rIns="0" bIns="0" rtlCol="0" anchor="ctr">
+            <a:normAutofit/>
+          </a:bodyPr>
+          <a:lstStyle/>
+          <a:p>
+            <a:pPr indent="0" marL="0">
+              <a:buNone/>
+            </a:pPr>
+            <a:r>
+              <a:rPr lang="en-US" sz="1500" b="1" dirty="0">
+                <a:solidFill>
+                  <a:srgbClr val="E58A3B"/>
+                </a:solidFill>
+              </a:rPr>
+              <a:t>EXAMPLES</a:t>
+            </a:r>
+            <a:endParaRPr lang="en-US" sz="1500" dirty="0"/>
+          </a:p>
+        </p:txBody>
+      </p:sp>
+      <p:sp>
+        <p:nvSpPr>
+          <p:cNvPr id="17" name="Text 15"/>
+          <p:cNvSpPr/>
+          <p:nvPr/>
+        </p:nvSpPr>
+        <p:spPr>
+          <a:xfrm>
+            <a:off x="2679192" y="3630168"/>
+            <a:ext cx="2743200" cy="365760"/>
+          </a:xfrm>
+          <a:prstGeom prst="rect">
+            <a:avLst/>
+          </a:prstGeom>
+          <a:noFill/>
+          <a:ln/>
+        </p:spPr>
+        <p:txBody>
+          <a:bodyPr wrap="square" lIns="254" tIns="254" rIns="254" bIns="254" rtlCol="0" anchor="ctr">
+            <a:normAutofit/>
+          </a:bodyPr>
+          <a:lstStyle/>
+          <a:p>
+            <a:pPr indent="0" marL="0">
+              <a:buNone/>
+            </a:pPr>
+            <a:r>
+              <a:rPr lang="en-US" sz="1500" dirty="0">
+                <a:solidFill>
+                  <a:srgbClr val="304245"/>
+                </a:solidFill>
+              </a:rPr>
+              <a:t>“That was admirable.”</a:t>
+            </a:r>
+            <a:endParaRPr lang="en-US" sz="1500" dirty="0"/>
+          </a:p>
+          <a:p>
+            <a:pPr indent="0" marL="0">
+              <a:buNone/>
+            </a:pPr>
+            <a:r>
+              <a:rPr lang="en-US" sz="1500" dirty="0">
+                <a:solidFill>
+                  <a:srgbClr val="304245"/>
+                </a:solidFill>
+              </a:rPr>
+              <a:t>“That was disgusting.”</a:t>
+            </a:r>
+            <a:endParaRPr lang="en-US" sz="1500" dirty="0"/>
+          </a:p>
+        </p:txBody>
+      </p:sp>
+      <p:sp>
+        <p:nvSpPr>
+          <p:cNvPr id="18" name="Text 16"/>
           <p:cNvSpPr/>
           <p:nvPr/>
         </p:nvSpPr>
@@ -3410,14 +3490,14 @@
               <a:buNone/>
             </a:pPr>
             <a:r>
-              <a:rPr lang="en-US" sz="1620" b="1" dirty="0">
+              <a:rPr lang="en-US" sz="1570" b="1" dirty="0">
                 <a:solidFill>
                   <a:srgbClr val="FFFFFF"/>
                 </a:solidFill>
               </a:rPr>
               <a:t>Some claims are overwhelmingly evaluative without being empty of description.</a:t>
             </a:r>
-            <a:endParaRPr lang="en-US" sz="1620" dirty="0"/>
+            <a:endParaRPr lang="en-US" sz="1570" dirty="0"/>
           </a:p>
         </p:txBody>
       </p:sp>
@@ -3663,8 +3743,8 @@
         </p:nvSpPr>
         <p:spPr>
           <a:xfrm>
-            <a:off x="1874520" y="5257800"/>
-            <a:ext cx="8138160" cy="0"/>
+            <a:off x="1325880" y="5285232"/>
+            <a:ext cx="9098280" cy="0"/>
           </a:xfrm>
           <a:prstGeom prst="line">
             <a:avLst/>
@@ -3688,8 +3768,8 @@
         </p:nvSpPr>
         <p:spPr>
           <a:xfrm>
-            <a:off x="1874520" y="5257800"/>
-            <a:ext cx="0" cy="-3154680"/>
+            <a:off x="1325880" y="5285232"/>
+            <a:ext cx="0" cy="-3364992"/>
           </a:xfrm>
           <a:prstGeom prst="line">
             <a:avLst/>
@@ -3713,8 +3793,8 @@
         </p:nvSpPr>
         <p:spPr>
           <a:xfrm>
-            <a:off x="9875520" y="5367528"/>
-            <a:ext cx="320040" cy="228600"/>
+            <a:off x="8823960" y="5431536"/>
+            <a:ext cx="1737360" cy="256032"/>
           </a:xfrm>
           <a:prstGeom prst="rect">
             <a:avLst/>
@@ -3732,14 +3812,14 @@
               <a:buNone/>
             </a:pPr>
             <a:r>
-              <a:rPr lang="en-US" sz="1500" b="1" dirty="0">
+              <a:rPr lang="en-US" sz="1200" b="1" dirty="0">
                 <a:solidFill>
                   <a:srgbClr val="6B7A7C"/>
                 </a:solidFill>
               </a:rPr>
-              <a:t>f</a:t>
-            </a:r>
-            <a:endParaRPr lang="en-US" sz="1500" dirty="0"/>
+              <a:t>descriptive content  f</a:t>
+            </a:r>
+            <a:endParaRPr lang="en-US" sz="1200" dirty="0"/>
           </a:p>
         </p:txBody>
       </p:sp>
@@ -3751,8 +3831,8 @@
         </p:nvSpPr>
         <p:spPr>
           <a:xfrm>
-            <a:off x="1554480" y="1938528"/>
-            <a:ext cx="274320" cy="228600"/>
+            <a:off x="914400" y="1700784"/>
+            <a:ext cx="1828800" cy="256032"/>
           </a:xfrm>
           <a:prstGeom prst="rect">
             <a:avLst/>
@@ -3766,18 +3846,18 @@
           </a:bodyPr>
           <a:lstStyle/>
           <a:p>
-            <a:pPr algn="ctr" indent="0" marL="0">
-              <a:buNone/>
-            </a:pPr>
-            <a:r>
-              <a:rPr lang="en-US" sz="1500" b="1" dirty="0">
+            <a:pPr algn="l" indent="0" marL="0">
+              <a:buNone/>
+            </a:pPr>
+            <a:r>
+              <a:rPr lang="en-US" sz="1200" b="1" dirty="0">
                 <a:solidFill>
                   <a:srgbClr val="6B7A7C"/>
                 </a:solidFill>
               </a:rPr>
-              <a:t>v</a:t>
-            </a:r>
-            <a:endParaRPr lang="en-US" sz="1500" dirty="0"/>
+              <a:t>evaluative content  v</a:t>
+            </a:r>
+            <a:endParaRPr lang="en-US" sz="1200" dirty="0"/>
           </a:p>
         </p:txBody>
       </p:sp>
@@ -3789,18 +3869,18 @@
         </p:nvSpPr>
         <p:spPr>
           <a:xfrm>
-            <a:off x="4114800" y="2331720"/>
-            <a:ext cx="3886200" cy="2103120"/>
+            <a:off x="3154680" y="2331720"/>
+            <a:ext cx="4572000" cy="2240280"/>
           </a:xfrm>
           <a:prstGeom prst="ellipse">
             <a:avLst/>
           </a:prstGeom>
           <a:solidFill>
             <a:srgbClr val="E8F4F3">
-              <a:alpha val="82000"/>
+              <a:alpha val="86000"/>
             </a:srgbClr>
           </a:solidFill>
-          <a:ln w="19050">
+          <a:ln w="20320">
             <a:solidFill>
               <a:srgbClr val="087C7E"/>
             </a:solidFill>
@@ -3816,8 +3896,8 @@
         </p:nvSpPr>
         <p:spPr>
           <a:xfrm>
-            <a:off x="4700016" y="2715768"/>
-            <a:ext cx="201168" cy="201168"/>
+            <a:off x="3977640" y="2724912"/>
+            <a:ext cx="182880" cy="182880"/>
           </a:xfrm>
           <a:prstGeom prst="ellipse">
             <a:avLst/>
@@ -3841,8 +3921,8 @@
         </p:nvSpPr>
         <p:spPr>
           <a:xfrm>
-            <a:off x="4937760" y="2660904"/>
-            <a:ext cx="1371600" cy="292608"/>
+            <a:off x="4178808" y="2670048"/>
+            <a:ext cx="1417320" cy="274320"/>
           </a:xfrm>
           <a:prstGeom prst="rect">
             <a:avLst/>
@@ -3879,8 +3959,8 @@
         </p:nvSpPr>
         <p:spPr>
           <a:xfrm>
-            <a:off x="5797296" y="3282696"/>
-            <a:ext cx="201168" cy="201168"/>
+            <a:off x="4983480" y="3127248"/>
+            <a:ext cx="182880" cy="182880"/>
           </a:xfrm>
           <a:prstGeom prst="ellipse">
             <a:avLst/>
@@ -3904,8 +3984,8 @@
         </p:nvSpPr>
         <p:spPr>
           <a:xfrm>
-            <a:off x="6035040" y="3227832"/>
-            <a:ext cx="1371600" cy="292608"/>
+            <a:off x="5184648" y="3072384"/>
+            <a:ext cx="1417320" cy="274320"/>
           </a:xfrm>
           <a:prstGeom prst="rect">
             <a:avLst/>
@@ -3942,8 +4022,8 @@
         </p:nvSpPr>
         <p:spPr>
           <a:xfrm>
-            <a:off x="6437376" y="2551176"/>
-            <a:ext cx="201168" cy="201168"/>
+            <a:off x="6172200" y="2606040"/>
+            <a:ext cx="182880" cy="182880"/>
           </a:xfrm>
           <a:prstGeom prst="ellipse">
             <a:avLst/>
@@ -3967,8 +4047,8 @@
         </p:nvSpPr>
         <p:spPr>
           <a:xfrm>
-            <a:off x="6675120" y="2496312"/>
-            <a:ext cx="1371600" cy="292608"/>
+            <a:off x="6373368" y="2551176"/>
+            <a:ext cx="1417320" cy="274320"/>
           </a:xfrm>
           <a:prstGeom prst="rect">
             <a:avLst/>
@@ -4005,8 +4085,8 @@
         </p:nvSpPr>
         <p:spPr>
           <a:xfrm>
-            <a:off x="4608576" y="3648456"/>
-            <a:ext cx="201168" cy="201168"/>
+            <a:off x="3886200" y="3703320"/>
+            <a:ext cx="182880" cy="182880"/>
           </a:xfrm>
           <a:prstGeom prst="ellipse">
             <a:avLst/>
@@ -4030,8 +4110,8 @@
         </p:nvSpPr>
         <p:spPr>
           <a:xfrm>
-            <a:off x="4846320" y="3593592"/>
-            <a:ext cx="1371600" cy="292608"/>
+            <a:off x="4087368" y="3648456"/>
+            <a:ext cx="1417320" cy="274320"/>
           </a:xfrm>
           <a:prstGeom prst="rect">
             <a:avLst/>
@@ -4068,8 +4148,8 @@
         </p:nvSpPr>
         <p:spPr>
           <a:xfrm>
-            <a:off x="6300216" y="3739896"/>
-            <a:ext cx="201168" cy="201168"/>
+            <a:off x="5852160" y="3730752"/>
+            <a:ext cx="182880" cy="182880"/>
           </a:xfrm>
           <a:prstGeom prst="ellipse">
             <a:avLst/>
@@ -4093,8 +4173,8 @@
         </p:nvSpPr>
         <p:spPr>
           <a:xfrm>
-            <a:off x="6537960" y="3685032"/>
-            <a:ext cx="1371600" cy="292608"/>
+            <a:off x="6053328" y="3675888"/>
+            <a:ext cx="1417320" cy="274320"/>
           </a:xfrm>
           <a:prstGeom prst="rect">
             <a:avLst/>
@@ -4409,8 +4489,8 @@
         </p:nvSpPr>
         <p:spPr>
           <a:xfrm>
-            <a:off x="1188720" y="2194560"/>
-            <a:ext cx="2103120" cy="1097280"/>
+            <a:off x="1234440" y="2148840"/>
+            <a:ext cx="2148840" cy="1097280"/>
           </a:xfrm>
           <a:prstGeom prst="rect">
             <a:avLst/>
@@ -4453,8 +4533,8 @@
         </p:nvSpPr>
         <p:spPr>
           <a:xfrm>
-            <a:off x="1874520" y="3566160"/>
-            <a:ext cx="731520" cy="320040"/>
+            <a:off x="1947672" y="3474720"/>
+            <a:ext cx="731520" cy="292608"/>
           </a:xfrm>
           <a:prstGeom prst="rect">
             <a:avLst/>
@@ -4472,14 +4552,14 @@
               <a:buNone/>
             </a:pPr>
             <a:r>
-              <a:rPr lang="en-US" sz="1500" b="1" dirty="0">
+              <a:rPr lang="en-US" sz="1400" b="1" dirty="0">
                 <a:solidFill>
                   <a:srgbClr val="6B7A7C"/>
                 </a:solidFill>
               </a:rPr>
               <a:t>t₀</a:t>
             </a:r>
-            <a:endParaRPr lang="en-US" sz="1500" dirty="0"/>
+            <a:endParaRPr lang="en-US" sz="1400" dirty="0"/>
           </a:p>
         </p:txBody>
       </p:sp>
@@ -4491,8 +4571,8 @@
         </p:nvSpPr>
         <p:spPr>
           <a:xfrm>
-            <a:off x="3429000" y="2743200"/>
-            <a:ext cx="1143000" cy="0"/>
+            <a:off x="3474720" y="2697480"/>
+            <a:ext cx="1051560" cy="0"/>
           </a:xfrm>
           <a:prstGeom prst="line">
             <a:avLst/>
@@ -4516,8 +4596,8 @@
         </p:nvSpPr>
         <p:spPr>
           <a:xfrm>
-            <a:off x="4709160" y="2194560"/>
-            <a:ext cx="2103120" cy="1097280"/>
+            <a:off x="4663440" y="2148840"/>
+            <a:ext cx="2148840" cy="1097280"/>
           </a:xfrm>
           <a:prstGeom prst="rect">
             <a:avLst/>
@@ -4560,8 +4640,8 @@
         </p:nvSpPr>
         <p:spPr>
           <a:xfrm>
-            <a:off x="5394960" y="3566160"/>
-            <a:ext cx="731520" cy="320040"/>
+            <a:off x="5376672" y="3474720"/>
+            <a:ext cx="731520" cy="292608"/>
           </a:xfrm>
           <a:prstGeom prst="rect">
             <a:avLst/>
@@ -4579,14 +4659,14 @@
               <a:buNone/>
             </a:pPr>
             <a:r>
-              <a:rPr lang="en-US" sz="1500" b="1" dirty="0">
+              <a:rPr lang="en-US" sz="1400" b="1" dirty="0">
                 <a:solidFill>
                   <a:srgbClr val="6B7A7C"/>
                 </a:solidFill>
               </a:rPr>
               <a:t>t₁</a:t>
             </a:r>
-            <a:endParaRPr lang="en-US" sz="1500" dirty="0"/>
+            <a:endParaRPr lang="en-US" sz="1400" dirty="0"/>
           </a:p>
         </p:txBody>
       </p:sp>
@@ -4598,8 +4678,8 @@
         </p:nvSpPr>
         <p:spPr>
           <a:xfrm>
-            <a:off x="6949440" y="2743200"/>
-            <a:ext cx="1143000" cy="0"/>
+            <a:off x="6903720" y="2697480"/>
+            <a:ext cx="1051560" cy="0"/>
           </a:xfrm>
           <a:prstGeom prst="line">
             <a:avLst/>
@@ -4623,8 +4703,8 @@
         </p:nvSpPr>
         <p:spPr>
           <a:xfrm>
-            <a:off x="8229600" y="2194560"/>
-            <a:ext cx="2103120" cy="1097280"/>
+            <a:off x="8092440" y="2148840"/>
+            <a:ext cx="2148840" cy="1097280"/>
           </a:xfrm>
           <a:prstGeom prst="rect">
             <a:avLst/>
@@ -4667,8 +4747,8 @@
         </p:nvSpPr>
         <p:spPr>
           <a:xfrm>
-            <a:off x="8915400" y="3566160"/>
-            <a:ext cx="731520" cy="320040"/>
+            <a:off x="8805672" y="3474720"/>
+            <a:ext cx="731520" cy="292608"/>
           </a:xfrm>
           <a:prstGeom prst="rect">
             <a:avLst/>
@@ -4686,14 +4766,14 @@
               <a:buNone/>
             </a:pPr>
             <a:r>
-              <a:rPr lang="en-US" sz="1500" b="1" dirty="0">
+              <a:rPr lang="en-US" sz="1400" b="1" dirty="0">
                 <a:solidFill>
                   <a:srgbClr val="6B7A7C"/>
                 </a:solidFill>
               </a:rPr>
               <a:t>t₂</a:t>
             </a:r>
-            <a:endParaRPr lang="en-US" sz="1500" dirty="0"/>
+            <a:endParaRPr lang="en-US" sz="1400" dirty="0"/>
           </a:p>
         </p:txBody>
       </p:sp>
@@ -4705,8 +4785,8 @@
         </p:nvSpPr>
         <p:spPr>
           <a:xfrm>
-            <a:off x="4251960" y="4663440"/>
-            <a:ext cx="3657600" cy="548640"/>
+            <a:off x="3931920" y="4434840"/>
+            <a:ext cx="4297680" cy="658368"/>
           </a:xfrm>
           <a:prstGeom prst="rect">
             <a:avLst/>
@@ -4724,14 +4804,14 @@
               <a:buNone/>
             </a:pPr>
             <a:r>
-              <a:rPr lang="en-US" sz="2600" b="1" dirty="0">
+              <a:rPr lang="en-US" sz="3100" b="1" dirty="0">
                 <a:solidFill>
                   <a:srgbClr val="142326"/>
                 </a:solidFill>
               </a:rPr>
               <a:t>Jₜ = (fₜ, vₜ)</a:t>
             </a:r>
-            <a:endParaRPr lang="en-US" sz="2600" dirty="0"/>
+            <a:endParaRPr lang="en-US" sz="3100" dirty="0"/>
           </a:p>
         </p:txBody>
       </p:sp>
@@ -4768,14 +4848,14 @@
               <a:buNone/>
             </a:pPr>
             <a:r>
-              <a:rPr lang="en-US" sz="1620" b="1" dirty="0">
+              <a:rPr lang="en-US" sz="1530" b="1" dirty="0">
                 <a:solidFill>
                   <a:srgbClr val="FFFFFF"/>
                 </a:solidFill>
               </a:rPr>
-              <a:t>The judgment changes because both our factual situation and our evaluative orientation can change.</a:t>
-            </a:r>
-            <a:endParaRPr lang="en-US" sz="1620" dirty="0"/>
+              <a:t>The judgment changes because both factual situation and evaluative orientation can change.</a:t>
+            </a:r>
+            <a:endParaRPr lang="en-US" sz="1530" dirty="0"/>
           </a:p>
         </p:txBody>
       </p:sp>
@@ -5021,8 +5101,8 @@
         </p:nvSpPr>
         <p:spPr>
           <a:xfrm>
-            <a:off x="1097280" y="2240280"/>
-            <a:ext cx="2880360" cy="1188720"/>
+            <a:off x="868680" y="2057400"/>
+            <a:ext cx="3154680" cy="1234440"/>
           </a:xfrm>
           <a:prstGeom prst="rect">
             <a:avLst/>
@@ -5079,8 +5159,8 @@
         </p:nvSpPr>
         <p:spPr>
           <a:xfrm>
-            <a:off x="8183880" y="2240280"/>
-            <a:ext cx="2880360" cy="1188720"/>
+            <a:off x="8183880" y="2057400"/>
+            <a:ext cx="3154680" cy="1234440"/>
           </a:xfrm>
           <a:prstGeom prst="rect">
             <a:avLst/>
@@ -5137,8 +5217,8 @@
         </p:nvSpPr>
         <p:spPr>
           <a:xfrm>
-            <a:off x="4114800" y="2834640"/>
-            <a:ext cx="3886200" cy="0"/>
+            <a:off x="4187952" y="2670048"/>
+            <a:ext cx="3813048" cy="0"/>
           </a:xfrm>
           <a:prstGeom prst="line">
             <a:avLst/>
@@ -5156,14 +5236,66 @@
       </p:sp>
       <p:sp>
         <p:nvSpPr>
-          <p:cNvPr id="11" name="Text 9"/>
-          <p:cNvSpPr/>
-          <p:nvPr/>
-        </p:nvSpPr>
-        <p:spPr>
-          <a:xfrm>
-            <a:off x="1828800" y="4069080"/>
-            <a:ext cx="4754880" cy="301752"/>
+          <p:cNvPr id="11" name="Shape 9"/>
+          <p:cNvSpPr/>
+          <p:nvPr/>
+        </p:nvSpPr>
+        <p:spPr>
+          <a:xfrm>
+            <a:off x="896112" y="3749040"/>
+            <a:ext cx="4754880" cy="1325880"/>
+          </a:xfrm>
+          <a:prstGeom prst="roundRect">
+            <a:avLst>
+              <a:gd name="adj" fmla="val 5517"/>
+            </a:avLst>
+          </a:prstGeom>
+          <a:solidFill>
+            <a:srgbClr val="EFF6E9"/>
+          </a:solidFill>
+          <a:ln w="13970">
+            <a:solidFill>
+              <a:srgbClr val="D8E2E0"/>
+            </a:solidFill>
+            <a:prstDash val="solid"/>
+          </a:ln>
+        </p:spPr>
+      </p:sp>
+      <p:sp>
+        <p:nvSpPr>
+          <p:cNvPr id="12" name="Shape 10"/>
+          <p:cNvSpPr/>
+          <p:nvPr/>
+        </p:nvSpPr>
+        <p:spPr>
+          <a:xfrm>
+            <a:off x="896112" y="3749040"/>
+            <a:ext cx="73152" cy="1325880"/>
+          </a:xfrm>
+          <a:prstGeom prst="rect">
+            <a:avLst/>
+          </a:prstGeom>
+          <a:solidFill>
+            <a:srgbClr val="6DAA45"/>
+          </a:solidFill>
+          <a:ln w="12700">
+            <a:solidFill>
+              <a:srgbClr val="6DAA45"/>
+            </a:solidFill>
+            <a:prstDash val="solid"/>
+          </a:ln>
+        </p:spPr>
+      </p:sp>
+      <p:sp>
+        <p:nvSpPr>
+          <p:cNvPr id="13" name="Text 11"/>
+          <p:cNvSpPr/>
+          <p:nvPr/>
+        </p:nvSpPr>
+        <p:spPr>
+          <a:xfrm>
+            <a:off x="1152144" y="3950208"/>
+            <a:ext cx="4297680" cy="329184"/>
           </a:xfrm>
           <a:prstGeom prst="rect">
             <a:avLst/>
@@ -5172,112 +5304,102 @@
           <a:ln/>
         </p:spPr>
         <p:txBody>
+          <a:bodyPr wrap="square" lIns="0" tIns="0" rIns="0" bIns="0" rtlCol="0" anchor="ctr">
+            <a:normAutofit/>
+          </a:bodyPr>
+          <a:lstStyle/>
+          <a:p>
+            <a:pPr indent="0" marL="0">
+              <a:buNone/>
+            </a:pPr>
+            <a:r>
+              <a:rPr lang="en-US" sz="1500" b="1" dirty="0">
+                <a:solidFill>
+                  <a:srgbClr val="6DAA45"/>
+                </a:solidFill>
+              </a:rPr>
+              <a:t>VALUES ASK</a:t>
+            </a:r>
+            <a:endParaRPr lang="en-US" sz="1500" dirty="0"/>
+          </a:p>
+        </p:txBody>
+      </p:sp>
+      <p:sp>
+        <p:nvSpPr>
+          <p:cNvPr id="14" name="Text 12"/>
+          <p:cNvSpPr/>
+          <p:nvPr/>
+        </p:nvSpPr>
+        <p:spPr>
+          <a:xfrm>
+            <a:off x="1152144" y="4407408"/>
+            <a:ext cx="4251960" cy="502920"/>
+          </a:xfrm>
+          <a:prstGeom prst="rect">
+            <a:avLst/>
+          </a:prstGeom>
+          <a:noFill/>
+          <a:ln/>
+        </p:spPr>
+        <p:txBody>
           <a:bodyPr wrap="square" lIns="254" tIns="254" rIns="254" bIns="254" rtlCol="0" anchor="ctr">
             <a:normAutofit/>
           </a:bodyPr>
           <a:lstStyle/>
           <a:p>
-            <a:pPr algn="l" indent="0" marL="0">
-              <a:buNone/>
-            </a:pPr>
-            <a:r>
-              <a:rPr lang="en-US" sz="1500" dirty="0">
+            <a:pPr indent="0" marL="0">
+              <a:buNone/>
+            </a:pPr>
+            <a:r>
+              <a:rPr lang="en-US" sz="1470" dirty="0">
                 <a:solidFill>
                   <a:srgbClr val="304245"/>
                 </a:solidFill>
               </a:rPr>
               <a:t>What counts as important?</a:t>
             </a:r>
-            <a:endParaRPr lang="en-US" sz="1500" dirty="0"/>
-          </a:p>
-        </p:txBody>
-      </p:sp>
-      <p:sp>
-        <p:nvSpPr>
-          <p:cNvPr id="12" name="Text 10"/>
-          <p:cNvSpPr/>
-          <p:nvPr/>
-        </p:nvSpPr>
-        <p:spPr>
-          <a:xfrm>
-            <a:off x="1828800" y="4498848"/>
-            <a:ext cx="4754880" cy="301752"/>
-          </a:xfrm>
-          <a:prstGeom prst="rect">
-            <a:avLst/>
-          </a:prstGeom>
-          <a:noFill/>
-          <a:ln/>
-        </p:spPr>
-        <p:txBody>
-          <a:bodyPr wrap="square" lIns="254" tIns="254" rIns="254" bIns="254" rtlCol="0" anchor="ctr">
-            <a:normAutofit/>
-          </a:bodyPr>
-          <a:lstStyle/>
-          <a:p>
-            <a:pPr algn="l" indent="0" marL="0">
-              <a:buNone/>
-            </a:pPr>
-            <a:r>
-              <a:rPr lang="en-US" sz="1500" dirty="0">
+            <a:endParaRPr lang="en-US" sz="1470" dirty="0"/>
+          </a:p>
+          <a:p>
+            <a:pPr indent="0" marL="0">
+              <a:buNone/>
+            </a:pPr>
+            <a:r>
+              <a:rPr lang="en-US" sz="1470" dirty="0">
                 <a:solidFill>
                   <a:srgbClr val="304245"/>
                 </a:solidFill>
               </a:rPr>
               <a:t>What counts as elegant?</a:t>
             </a:r>
-            <a:endParaRPr lang="en-US" sz="1500" dirty="0"/>
-          </a:p>
-        </p:txBody>
-      </p:sp>
-      <p:sp>
-        <p:nvSpPr>
-          <p:cNvPr id="13" name="Text 11"/>
-          <p:cNvSpPr/>
-          <p:nvPr/>
-        </p:nvSpPr>
-        <p:spPr>
-          <a:xfrm>
-            <a:off x="1828800" y="4928616"/>
-            <a:ext cx="4754880" cy="301752"/>
-          </a:xfrm>
-          <a:prstGeom prst="rect">
-            <a:avLst/>
-          </a:prstGeom>
-          <a:noFill/>
-          <a:ln/>
-        </p:spPr>
-        <p:txBody>
-          <a:bodyPr wrap="square" lIns="254" tIns="254" rIns="254" bIns="254" rtlCol="0" anchor="ctr">
-            <a:normAutofit/>
-          </a:bodyPr>
-          <a:lstStyle/>
-          <a:p>
-            <a:pPr algn="l" indent="0" marL="0">
-              <a:buNone/>
-            </a:pPr>
-            <a:r>
-              <a:rPr lang="en-US" sz="1500" dirty="0">
+            <a:endParaRPr lang="en-US" sz="1470" dirty="0"/>
+          </a:p>
+          <a:p>
+            <a:pPr indent="0" marL="0">
+              <a:buNone/>
+            </a:pPr>
+            <a:r>
+              <a:rPr lang="en-US" sz="1470" dirty="0">
                 <a:solidFill>
                   <a:srgbClr val="304245"/>
                 </a:solidFill>
               </a:rPr>
               <a:t>What counts as explanation?</a:t>
             </a:r>
-            <a:endParaRPr lang="en-US" sz="1500" dirty="0"/>
-          </a:p>
-        </p:txBody>
-      </p:sp>
-      <p:sp>
-        <p:nvSpPr>
-          <p:cNvPr id="14" name="Text 12"/>
-          <p:cNvSpPr/>
-          <p:nvPr/>
-        </p:nvSpPr>
-        <p:spPr>
-          <a:xfrm>
-            <a:off x="7223760" y="4069080"/>
-            <a:ext cx="1417320" cy="402336"/>
+            <a:endParaRPr lang="en-US" sz="1470" dirty="0"/>
+          </a:p>
+        </p:txBody>
+      </p:sp>
+      <p:sp>
+        <p:nvSpPr>
+          <p:cNvPr id="15" name="Text 13"/>
+          <p:cNvSpPr/>
+          <p:nvPr/>
+        </p:nvSpPr>
+        <p:spPr>
+          <a:xfrm>
+            <a:off x="6629400" y="3931920"/>
+            <a:ext cx="1508760" cy="438912"/>
           </a:xfrm>
           <a:prstGeom prst="rect">
             <a:avLst/>
@@ -5314,14 +5436,14 @@
       </p:sp>
       <p:sp>
         <p:nvSpPr>
-          <p:cNvPr id="15" name="Text 13"/>
-          <p:cNvSpPr/>
-          <p:nvPr/>
-        </p:nvSpPr>
-        <p:spPr>
-          <a:xfrm>
-            <a:off x="8823960" y="4069080"/>
-            <a:ext cx="1417320" cy="402336"/>
+          <p:cNvPr id="16" name="Text 14"/>
+          <p:cNvSpPr/>
+          <p:nvPr/>
+        </p:nvSpPr>
+        <p:spPr>
+          <a:xfrm>
+            <a:off x="8412480" y="3931920"/>
+            <a:ext cx="1508760" cy="438912"/>
           </a:xfrm>
           <a:prstGeom prst="rect">
             <a:avLst/>
@@ -5358,14 +5480,14 @@
       </p:sp>
       <p:sp>
         <p:nvSpPr>
-          <p:cNvPr id="16" name="Text 14"/>
-          <p:cNvSpPr/>
-          <p:nvPr/>
-        </p:nvSpPr>
-        <p:spPr>
-          <a:xfrm>
-            <a:off x="7223760" y="4636008"/>
-            <a:ext cx="1417320" cy="402336"/>
+          <p:cNvPr id="17" name="Text 15"/>
+          <p:cNvSpPr/>
+          <p:nvPr/>
+        </p:nvSpPr>
+        <p:spPr>
+          <a:xfrm>
+            <a:off x="6629400" y="4526280"/>
+            <a:ext cx="1508760" cy="438912"/>
           </a:xfrm>
           <a:prstGeom prst="rect">
             <a:avLst/>
@@ -5402,14 +5524,14 @@
       </p:sp>
       <p:sp>
         <p:nvSpPr>
-          <p:cNvPr id="17" name="Text 15"/>
-          <p:cNvSpPr/>
-          <p:nvPr/>
-        </p:nvSpPr>
-        <p:spPr>
-          <a:xfrm>
-            <a:off x="8823960" y="4636008"/>
-            <a:ext cx="1417320" cy="402336"/>
+          <p:cNvPr id="18" name="Text 16"/>
+          <p:cNvSpPr/>
+          <p:nvPr/>
+        </p:nvSpPr>
+        <p:spPr>
+          <a:xfrm>
+            <a:off x="8412480" y="4526280"/>
+            <a:ext cx="1508760" cy="438912"/>
           </a:xfrm>
           <a:prstGeom prst="rect">
             <a:avLst/>
@@ -5446,7 +5568,7 @@
       </p:sp>
       <p:sp>
         <p:nvSpPr>
-          <p:cNvPr id="18" name="Text 16"/>
+          <p:cNvPr id="19" name="Text 17"/>
           <p:cNvSpPr/>
           <p:nvPr/>
         </p:nvSpPr>
@@ -5477,14 +5599,14 @@
               <a:buNone/>
             </a:pPr>
             <a:r>
-              <a:rPr lang="en-US" sz="1620" b="1" dirty="0">
+              <a:rPr lang="en-US" sz="1500" b="1" dirty="0">
                 <a:solidFill>
                   <a:srgbClr val="FFFFFF"/>
                 </a:solidFill>
               </a:rPr>
-              <a:t>Values do not dictate the answer. They help determine what counts as a question and a good answer.</a:t>
-            </a:r>
-            <a:endParaRPr lang="en-US" sz="1620" dirty="0"/>
+              <a:t>Values do not dictate the answer. They help determine the question and the standard of success.</a:t>
+            </a:r>
+            <a:endParaRPr lang="en-US" sz="1500" dirty="0"/>
           </a:p>
         </p:txBody>
       </p:sp>
@@ -5730,8 +5852,8 @@
         </p:nvSpPr>
         <p:spPr>
           <a:xfrm>
-            <a:off x="777240" y="2331720"/>
-            <a:ext cx="1600200" cy="914400"/>
+            <a:off x="713232" y="2148840"/>
+            <a:ext cx="1645920" cy="896112"/>
           </a:xfrm>
           <a:prstGeom prst="rect">
             <a:avLst/>
@@ -5774,14 +5896,14 @@
         </p:nvSpPr>
         <p:spPr>
           <a:xfrm>
-            <a:off x="2441448" y="2788920"/>
-            <a:ext cx="457200" cy="0"/>
+            <a:off x="2423160" y="2596896"/>
+            <a:ext cx="411480" cy="0"/>
           </a:xfrm>
           <a:prstGeom prst="line">
             <a:avLst/>
           </a:prstGeom>
           <a:noFill/>
-          <a:ln w="27940">
+          <a:ln w="26670">
             <a:solidFill>
               <a:srgbClr val="6B7A7C"/>
             </a:solidFill>
@@ -5799,8 +5921,8 @@
         </p:nvSpPr>
         <p:spPr>
           <a:xfrm>
-            <a:off x="2971800" y="2331720"/>
-            <a:ext cx="1600200" cy="914400"/>
+            <a:off x="2907792" y="2148840"/>
+            <a:ext cx="1645920" cy="896112"/>
           </a:xfrm>
           <a:prstGeom prst="rect">
             <a:avLst/>
@@ -5843,14 +5965,14 @@
         </p:nvSpPr>
         <p:spPr>
           <a:xfrm>
-            <a:off x="4636008" y="2788920"/>
-            <a:ext cx="457200" cy="0"/>
+            <a:off x="4617720" y="2596896"/>
+            <a:ext cx="411480" cy="0"/>
           </a:xfrm>
           <a:prstGeom prst="line">
             <a:avLst/>
           </a:prstGeom>
           <a:noFill/>
-          <a:ln w="27940">
+          <a:ln w="26670">
             <a:solidFill>
               <a:srgbClr val="6B7A7C"/>
             </a:solidFill>
@@ -5868,8 +5990,8 @@
         </p:nvSpPr>
         <p:spPr>
           <a:xfrm>
-            <a:off x="5166360" y="2331720"/>
-            <a:ext cx="1600200" cy="914400"/>
+            <a:off x="5102352" y="2148840"/>
+            <a:ext cx="1645920" cy="896112"/>
           </a:xfrm>
           <a:prstGeom prst="rect">
             <a:avLst/>
@@ -5912,14 +6034,14 @@
         </p:nvSpPr>
         <p:spPr>
           <a:xfrm>
-            <a:off x="6830568" y="2788920"/>
-            <a:ext cx="457200" cy="0"/>
+            <a:off x="6812280" y="2596896"/>
+            <a:ext cx="411480" cy="0"/>
           </a:xfrm>
           <a:prstGeom prst="line">
             <a:avLst/>
           </a:prstGeom>
           <a:noFill/>
-          <a:ln w="27940">
+          <a:ln w="26670">
             <a:solidFill>
               <a:srgbClr val="6B7A7C"/>
             </a:solidFill>
@@ -5937,8 +6059,8 @@
         </p:nvSpPr>
         <p:spPr>
           <a:xfrm>
-            <a:off x="7360920" y="2331720"/>
-            <a:ext cx="1600200" cy="914400"/>
+            <a:off x="7296912" y="2148840"/>
+            <a:ext cx="1645920" cy="896112"/>
           </a:xfrm>
           <a:prstGeom prst="rect">
             <a:avLst/>
@@ -5981,14 +6103,14 @@
         </p:nvSpPr>
         <p:spPr>
           <a:xfrm>
-            <a:off x="9025128" y="2788920"/>
-            <a:ext cx="457200" cy="0"/>
+            <a:off x="9006840" y="2596896"/>
+            <a:ext cx="411480" cy="0"/>
           </a:xfrm>
           <a:prstGeom prst="line">
             <a:avLst/>
           </a:prstGeom>
           <a:noFill/>
-          <a:ln w="27940">
+          <a:ln w="26670">
             <a:solidFill>
               <a:srgbClr val="6B7A7C"/>
             </a:solidFill>
@@ -6006,8 +6128,8 @@
         </p:nvSpPr>
         <p:spPr>
           <a:xfrm>
-            <a:off x="9555480" y="2331720"/>
-            <a:ext cx="1600200" cy="914400"/>
+            <a:off x="9491472" y="2148840"/>
+            <a:ext cx="1645920" cy="896112"/>
           </a:xfrm>
           <a:prstGeom prst="rect">
             <a:avLst/>
@@ -6050,8 +6172,8 @@
         </p:nvSpPr>
         <p:spPr>
           <a:xfrm>
-            <a:off x="822960" y="3794760"/>
-            <a:ext cx="1508760" cy="274320"/>
+            <a:off x="667512" y="3337560"/>
+            <a:ext cx="1737360" cy="256032"/>
           </a:xfrm>
           <a:prstGeom prst="rect">
             <a:avLst/>
@@ -6069,14 +6191,14 @@
               <a:buNone/>
             </a:pPr>
             <a:r>
-              <a:rPr lang="en-US" sz="1300" dirty="0">
+              <a:rPr lang="en-US" sz="1200" dirty="0">
                 <a:solidFill>
                   <a:srgbClr val="6B7A7C"/>
                 </a:solidFill>
               </a:rPr>
               <a:t>standards</a:t>
             </a:r>
-            <a:endParaRPr lang="en-US" sz="1300" dirty="0"/>
+            <a:endParaRPr lang="en-US" sz="1200" dirty="0"/>
           </a:p>
         </p:txBody>
       </p:sp>
@@ -6088,8 +6210,8 @@
         </p:nvSpPr>
         <p:spPr>
           <a:xfrm>
-            <a:off x="3017520" y="3794760"/>
-            <a:ext cx="1508760" cy="274320"/>
+            <a:off x="2862072" y="3337560"/>
+            <a:ext cx="1737360" cy="256032"/>
           </a:xfrm>
           <a:prstGeom prst="rect">
             <a:avLst/>
@@ -6107,14 +6229,14 @@
               <a:buNone/>
             </a:pPr>
             <a:r>
-              <a:rPr lang="en-US" sz="1300" dirty="0">
+              <a:rPr lang="en-US" sz="1200" dirty="0">
                 <a:solidFill>
                   <a:srgbClr val="6B7A7C"/>
                 </a:solidFill>
               </a:rPr>
               <a:t>theory</a:t>
             </a:r>
-            <a:endParaRPr lang="en-US" sz="1300" dirty="0"/>
+            <a:endParaRPr lang="en-US" sz="1200" dirty="0"/>
           </a:p>
         </p:txBody>
       </p:sp>
@@ -6126,8 +6248,8 @@
         </p:nvSpPr>
         <p:spPr>
           <a:xfrm>
-            <a:off x="4956048" y="3794760"/>
-            <a:ext cx="2011680" cy="274320"/>
+            <a:off x="5056632" y="3337560"/>
+            <a:ext cx="1737360" cy="256032"/>
           </a:xfrm>
           <a:prstGeom prst="rect">
             <a:avLst/>
@@ -6145,14 +6267,14 @@
               <a:buNone/>
             </a:pPr>
             <a:r>
-              <a:rPr lang="en-US" sz="1300" dirty="0">
+              <a:rPr lang="en-US" sz="1200" dirty="0">
                 <a:solidFill>
                   <a:srgbClr val="6B7A7C"/>
                 </a:solidFill>
               </a:rPr>
               <a:t>revised standards</a:t>
             </a:r>
-            <a:endParaRPr lang="en-US" sz="1300" dirty="0"/>
+            <a:endParaRPr lang="en-US" sz="1200" dirty="0"/>
           </a:p>
         </p:txBody>
       </p:sp>
@@ -6164,8 +6286,8 @@
         </p:nvSpPr>
         <p:spPr>
           <a:xfrm>
-            <a:off x="7315200" y="3794760"/>
-            <a:ext cx="1737360" cy="274320"/>
+            <a:off x="7251192" y="3337560"/>
+            <a:ext cx="1737360" cy="256032"/>
           </a:xfrm>
           <a:prstGeom prst="rect">
             <a:avLst/>
@@ -6183,14 +6305,14 @@
               <a:buNone/>
             </a:pPr>
             <a:r>
-              <a:rPr lang="en-US" sz="1300" dirty="0">
+              <a:rPr lang="en-US" sz="1200" dirty="0">
                 <a:solidFill>
                   <a:srgbClr val="6B7A7C"/>
                 </a:solidFill>
               </a:rPr>
               <a:t>new theory</a:t>
             </a:r>
-            <a:endParaRPr lang="en-US" sz="1300" dirty="0"/>
+            <a:endParaRPr lang="en-US" sz="1200" dirty="0"/>
           </a:p>
         </p:txBody>
       </p:sp>
@@ -6202,8 +6324,8 @@
         </p:nvSpPr>
         <p:spPr>
           <a:xfrm>
-            <a:off x="9509760" y="3794760"/>
-            <a:ext cx="1737360" cy="274320"/>
+            <a:off x="9445752" y="3337560"/>
+            <a:ext cx="1737360" cy="256032"/>
           </a:xfrm>
           <a:prstGeom prst="rect">
             <a:avLst/>
@@ -6221,14 +6343,14 @@
               <a:buNone/>
             </a:pPr>
             <a:r>
-              <a:rPr lang="en-US" sz="1300" dirty="0">
+              <a:rPr lang="en-US" sz="1200" dirty="0">
                 <a:solidFill>
                   <a:srgbClr val="6B7A7C"/>
                 </a:solidFill>
               </a:rPr>
               <a:t>new values</a:t>
             </a:r>
-            <a:endParaRPr lang="en-US" sz="1300" dirty="0"/>
+            <a:endParaRPr lang="en-US" sz="1200" dirty="0"/>
           </a:p>
         </p:txBody>
       </p:sp>
@@ -6240,8 +6362,8 @@
         </p:nvSpPr>
         <p:spPr>
           <a:xfrm>
-            <a:off x="2788920" y="4572000"/>
-            <a:ext cx="6583680" cy="548640"/>
+            <a:off x="2788920" y="4343400"/>
+            <a:ext cx="6583680" cy="621792"/>
           </a:xfrm>
           <a:prstGeom prst="rect">
             <a:avLst/>
@@ -6259,14 +6381,14 @@
               <a:buNone/>
             </a:pPr>
             <a:r>
-              <a:rPr lang="en-US" sz="2500" b="1" dirty="0">
+              <a:rPr lang="en-US" sz="2800" b="1" dirty="0">
                 <a:solidFill>
                   <a:srgbClr val="142326"/>
                 </a:solidFill>
               </a:rPr>
               <a:t>V₀ → T₁ → V₁ → T₂ → V₂ → …</a:t>
             </a:r>
-            <a:endParaRPr lang="en-US" sz="2500" dirty="0"/>
+            <a:endParaRPr lang="en-US" sz="2800" dirty="0"/>
           </a:p>
         </p:txBody>
       </p:sp>
@@ -6308,7 +6430,7 @@
                   <a:srgbClr val="FFFFFF"/>
                 </a:solidFill>
               </a:rPr>
-              <a:t>Inquiry is recursive: standards shape inquiry; successful inquiry can reshape standards.</a:t>
+              <a:t>Standards shape inquiry; successful inquiry can reshape standards.</a:t>
             </a:r>
             <a:endParaRPr lang="en-US" sz="1620" dirty="0"/>
           </a:p>
@@ -6556,8 +6678,8 @@
         </p:nvSpPr>
         <p:spPr>
           <a:xfrm>
-            <a:off x="594360" y="2240280"/>
-            <a:ext cx="2240280" cy="1143000"/>
+            <a:off x="658368" y="2148840"/>
+            <a:ext cx="2148840" cy="1078992"/>
           </a:xfrm>
           <a:prstGeom prst="rect">
             <a:avLst/>
@@ -6614,14 +6736,14 @@
         </p:nvSpPr>
         <p:spPr>
           <a:xfrm>
-            <a:off x="2926080" y="2816352"/>
-            <a:ext cx="228600" cy="0"/>
+            <a:off x="2880360" y="2688336"/>
+            <a:ext cx="265176" cy="0"/>
           </a:xfrm>
           <a:prstGeom prst="line">
             <a:avLst/>
           </a:prstGeom>
           <a:noFill/>
-          <a:ln w="27940">
+          <a:ln w="26670">
             <a:solidFill>
               <a:srgbClr val="6B7A7C"/>
             </a:solidFill>
@@ -6639,8 +6761,8 @@
         </p:nvSpPr>
         <p:spPr>
           <a:xfrm>
-            <a:off x="3246120" y="2240280"/>
-            <a:ext cx="2240280" cy="1143000"/>
+            <a:off x="3246120" y="2148840"/>
+            <a:ext cx="2148840" cy="1078992"/>
           </a:xfrm>
           <a:prstGeom prst="rect">
             <a:avLst/>
@@ -6697,14 +6819,14 @@
         </p:nvSpPr>
         <p:spPr>
           <a:xfrm>
-            <a:off x="5577840" y="2816352"/>
-            <a:ext cx="228600" cy="0"/>
+            <a:off x="5468112" y="2688336"/>
+            <a:ext cx="265176" cy="0"/>
           </a:xfrm>
           <a:prstGeom prst="line">
             <a:avLst/>
           </a:prstGeom>
           <a:noFill/>
-          <a:ln w="27940">
+          <a:ln w="26670">
             <a:solidFill>
               <a:srgbClr val="6B7A7C"/>
             </a:solidFill>
@@ -6722,8 +6844,8 @@
         </p:nvSpPr>
         <p:spPr>
           <a:xfrm>
-            <a:off x="5897880" y="2240280"/>
-            <a:ext cx="2240280" cy="1143000"/>
+            <a:off x="5833872" y="2148840"/>
+            <a:ext cx="2148840" cy="1078992"/>
           </a:xfrm>
           <a:prstGeom prst="rect">
             <a:avLst/>
@@ -6780,14 +6902,14 @@
         </p:nvSpPr>
         <p:spPr>
           <a:xfrm>
-            <a:off x="8229600" y="2816352"/>
-            <a:ext cx="228600" cy="0"/>
+            <a:off x="8055864" y="2688336"/>
+            <a:ext cx="265176" cy="0"/>
           </a:xfrm>
           <a:prstGeom prst="line">
             <a:avLst/>
           </a:prstGeom>
           <a:noFill/>
-          <a:ln w="27940">
+          <a:ln w="26670">
             <a:solidFill>
               <a:srgbClr val="6B7A7C"/>
             </a:solidFill>
@@ -6805,8 +6927,8 @@
         </p:nvSpPr>
         <p:spPr>
           <a:xfrm>
-            <a:off x="8549640" y="2240280"/>
-            <a:ext cx="2240280" cy="1143000"/>
+            <a:off x="8421624" y="2148840"/>
+            <a:ext cx="2148840" cy="1078992"/>
           </a:xfrm>
           <a:prstGeom prst="rect">
             <a:avLst/>
@@ -6863,8 +6985,8 @@
         </p:nvSpPr>
         <p:spPr>
           <a:xfrm>
-            <a:off x="9646920" y="3657600"/>
-            <a:ext cx="-8138160" cy="1051560"/>
+            <a:off x="1783080" y="3886200"/>
+            <a:ext cx="7680960" cy="0"/>
           </a:xfrm>
           <a:prstGeom prst="line">
             <a:avLst/>
@@ -6875,8 +6997,8 @@
               <a:srgbClr val="087C7E"/>
             </a:solidFill>
             <a:prstDash val="solid"/>
-            <a:headEnd type="none"/>
-            <a:tailEnd type="triangle"/>
+            <a:headEnd type="triangle"/>
+            <a:tailEnd type="none"/>
           </a:ln>
         </p:spPr>
       </p:sp>
@@ -6888,8 +7010,8 @@
         </p:nvSpPr>
         <p:spPr>
           <a:xfrm>
-            <a:off x="5440680" y="4160520"/>
-            <a:ext cx="1280160" cy="320040"/>
+            <a:off x="4297680" y="4069080"/>
+            <a:ext cx="3657600" cy="310896"/>
           </a:xfrm>
           <a:prstGeom prst="rect">
             <a:avLst/>
@@ -6907,14 +7029,14 @@
               <a:buNone/>
             </a:pPr>
             <a:r>
-              <a:rPr lang="en-US" sz="1400" b="1" dirty="0">
+              <a:rPr lang="en-US" sz="1300" b="1" dirty="0">
                 <a:solidFill>
                   <a:srgbClr val="087C7E"/>
                 </a:solidFill>
               </a:rPr>
-              <a:t>feedback</a:t>
-            </a:r>
-            <a:endParaRPr lang="en-US" sz="1400" dirty="0"/>
+              <a:t>feedback: artifact changes expectation</a:t>
+            </a:r>
+            <a:endParaRPr lang="en-US" sz="1300" dirty="0"/>
           </a:p>
         </p:txBody>
       </p:sp>
@@ -6926,8 +7048,8 @@
         </p:nvSpPr>
         <p:spPr>
           <a:xfrm>
-            <a:off x="4114800" y="5074920"/>
-            <a:ext cx="3931920" cy="502920"/>
+            <a:off x="4069080" y="4709160"/>
+            <a:ext cx="4069080" cy="530352"/>
           </a:xfrm>
           <a:prstGeom prst="rect">
             <a:avLst/>
@@ -6989,14 +7111,14 @@
               <a:buNone/>
             </a:pPr>
             <a:r>
-              <a:rPr lang="en-US" sz="1620" b="1" dirty="0">
+              <a:rPr lang="en-US" sz="1530" b="1" dirty="0">
                 <a:solidFill>
                   <a:srgbClr val="FFFFFF"/>
                 </a:solidFill>
               </a:rPr>
-              <a:t>Aesthetic and practical values shape artifacts; living with artifacts reshapes taste and expectation.</a:t>
-            </a:r>
-            <a:endParaRPr lang="en-US" sz="1620" dirty="0"/>
+              <a:t>Aesthetic and practical values shape artifacts; living with artifacts reshapes taste.</a:t>
+            </a:r>
+            <a:endParaRPr lang="en-US" sz="1530" dirty="0"/>
           </a:p>
         </p:txBody>
       </p:sp>
@@ -7242,8 +7364,8 @@
         </p:nvSpPr>
         <p:spPr>
           <a:xfrm>
-            <a:off x="594360" y="2331720"/>
-            <a:ext cx="1783080" cy="1051560"/>
+            <a:off x="502920" y="2194560"/>
+            <a:ext cx="1828800" cy="1024128"/>
           </a:xfrm>
           <a:prstGeom prst="rect">
             <a:avLst/>
@@ -7300,14 +7422,14 @@
         </p:nvSpPr>
         <p:spPr>
           <a:xfrm>
-            <a:off x="2441448" y="2862072"/>
-            <a:ext cx="301752" cy="0"/>
+            <a:off x="2404872" y="2706624"/>
+            <a:ext cx="256032" cy="0"/>
           </a:xfrm>
           <a:prstGeom prst="line">
             <a:avLst/>
           </a:prstGeom>
           <a:noFill/>
-          <a:ln w="27940">
+          <a:ln w="26670">
             <a:solidFill>
               <a:srgbClr val="6B7A7C"/>
             </a:solidFill>
@@ -7325,8 +7447,8 @@
         </p:nvSpPr>
         <p:spPr>
           <a:xfrm>
-            <a:off x="2880360" y="2331720"/>
-            <a:ext cx="1783080" cy="1051560"/>
+            <a:off x="2770632" y="2194560"/>
+            <a:ext cx="1828800" cy="1024128"/>
           </a:xfrm>
           <a:prstGeom prst="rect">
             <a:avLst/>
@@ -7383,14 +7505,14 @@
         </p:nvSpPr>
         <p:spPr>
           <a:xfrm>
-            <a:off x="4727448" y="2862072"/>
-            <a:ext cx="301752" cy="0"/>
+            <a:off x="4672584" y="2706624"/>
+            <a:ext cx="256032" cy="0"/>
           </a:xfrm>
           <a:prstGeom prst="line">
             <a:avLst/>
           </a:prstGeom>
           <a:noFill/>
-          <a:ln w="27940">
+          <a:ln w="26670">
             <a:solidFill>
               <a:srgbClr val="6B7A7C"/>
             </a:solidFill>
@@ -7408,8 +7530,8 @@
         </p:nvSpPr>
         <p:spPr>
           <a:xfrm>
-            <a:off x="5166360" y="2331720"/>
-            <a:ext cx="1783080" cy="1051560"/>
+            <a:off x="5038344" y="2194560"/>
+            <a:ext cx="1828800" cy="1024128"/>
           </a:xfrm>
           <a:prstGeom prst="rect">
             <a:avLst/>
@@ -7466,14 +7588,14 @@
         </p:nvSpPr>
         <p:spPr>
           <a:xfrm>
-            <a:off x="7013448" y="2862072"/>
-            <a:ext cx="301752" cy="0"/>
+            <a:off x="6940296" y="2706624"/>
+            <a:ext cx="256032" cy="0"/>
           </a:xfrm>
           <a:prstGeom prst="line">
             <a:avLst/>
           </a:prstGeom>
           <a:noFill/>
-          <a:ln w="27940">
+          <a:ln w="26670">
             <a:solidFill>
               <a:srgbClr val="6B7A7C"/>
             </a:solidFill>
@@ -7491,8 +7613,8 @@
         </p:nvSpPr>
         <p:spPr>
           <a:xfrm>
-            <a:off x="7452360" y="2331720"/>
-            <a:ext cx="1783080" cy="1051560"/>
+            <a:off x="7306056" y="2194560"/>
+            <a:ext cx="1828800" cy="1024128"/>
           </a:xfrm>
           <a:prstGeom prst="rect">
             <a:avLst/>
@@ -7549,14 +7671,14 @@
         </p:nvSpPr>
         <p:spPr>
           <a:xfrm>
-            <a:off x="9299448" y="2862072"/>
-            <a:ext cx="301752" cy="0"/>
+            <a:off x="9208008" y="2706624"/>
+            <a:ext cx="256032" cy="0"/>
           </a:xfrm>
           <a:prstGeom prst="line">
             <a:avLst/>
           </a:prstGeom>
           <a:noFill/>
-          <a:ln w="27940">
+          <a:ln w="26670">
             <a:solidFill>
               <a:srgbClr val="6B7A7C"/>
             </a:solidFill>
@@ -7574,8 +7696,8 @@
         </p:nvSpPr>
         <p:spPr>
           <a:xfrm>
-            <a:off x="9738360" y="2331720"/>
-            <a:ext cx="1783080" cy="1051560"/>
+            <a:off x="9573768" y="2194560"/>
+            <a:ext cx="1828800" cy="1024128"/>
           </a:xfrm>
           <a:prstGeom prst="rect">
             <a:avLst/>
@@ -7632,20 +7754,20 @@
         </p:nvSpPr>
         <p:spPr>
           <a:xfrm>
-            <a:off x="10698480" y="3749040"/>
-            <a:ext cx="-9281160" cy="1097280"/>
+            <a:off x="1417320" y="3950208"/>
+            <a:ext cx="9052560" cy="0"/>
           </a:xfrm>
           <a:prstGeom prst="line">
             <a:avLst/>
           </a:prstGeom>
           <a:noFill/>
-          <a:ln w="25400">
+          <a:ln w="26670">
             <a:solidFill>
               <a:srgbClr val="087C7E"/>
             </a:solidFill>
             <a:prstDash val="solid"/>
-            <a:headEnd type="none"/>
-            <a:tailEnd type="triangle"/>
+            <a:headEnd type="triangle"/>
+            <a:tailEnd type="none"/>
           </a:ln>
         </p:spPr>
       </p:sp>
@@ -7657,8 +7779,8 @@
         </p:nvSpPr>
         <p:spPr>
           <a:xfrm>
-            <a:off x="3383280" y="4434840"/>
-            <a:ext cx="5486400" cy="411480"/>
+            <a:off x="3429000" y="4142232"/>
+            <a:ext cx="5349240" cy="347472"/>
           </a:xfrm>
           <a:prstGeom prst="rect">
             <a:avLst/>
@@ -7676,14 +7798,14 @@
               <a:buNone/>
             </a:pPr>
             <a:r>
-              <a:rPr lang="en-US" sz="1500" b="1" dirty="0">
+              <a:rPr lang="en-US" sz="1350" b="1" dirty="0">
                 <a:solidFill>
                   <a:srgbClr val="087C7E"/>
                 </a:solidFill>
               </a:rPr>
-              <a:t>new state → new evidence → new evaluation</a:t>
-            </a:r>
-            <a:endParaRPr lang="en-US" sz="1500" dirty="0"/>
+              <a:t>new world → new evidence → new evaluation</a:t>
+            </a:r>
+            <a:endParaRPr lang="en-US" sz="1350" dirty="0"/>
           </a:p>
         </p:txBody>
       </p:sp>
@@ -7720,14 +7842,14 @@
               <a:buNone/>
             </a:pPr>
             <a:r>
-              <a:rPr lang="en-US" sz="1620" b="1" dirty="0">
+              <a:rPr lang="en-US" sz="1500" b="1" dirty="0">
                 <a:solidFill>
                   <a:srgbClr val="FFFFFF"/>
                 </a:solidFill>
               </a:rPr>
-              <a:t>We do not merely observe state space. Evaluation helps determine which state we try to move into.</a:t>
-            </a:r>
-            <a:endParaRPr lang="en-US" sz="1620" dirty="0"/>
+              <a:t>We do not merely observe state space. Evaluation helps choose the next state.</a:t>
+            </a:r>
+            <a:endParaRPr lang="en-US" sz="1500" dirty="0"/>
           </a:p>
         </p:txBody>
       </p:sp>
@@ -7973,8 +8095,8 @@
         </p:nvSpPr>
         <p:spPr>
           <a:xfrm>
-            <a:off x="960120" y="2057400"/>
-            <a:ext cx="2834640" cy="1097280"/>
+            <a:off x="914400" y="1965960"/>
+            <a:ext cx="2743200" cy="1005840"/>
           </a:xfrm>
           <a:prstGeom prst="rect">
             <a:avLst/>
@@ -7998,28 +8120,28 @@
               <a:buNone/>
             </a:pPr>
             <a:r>
-              <a:rPr lang="en-US" sz="2000" b="1" dirty="0">
+              <a:rPr lang="en-US" sz="1900" b="1" dirty="0">
                 <a:solidFill>
                   <a:srgbClr val="4EA7C4"/>
                 </a:solidFill>
               </a:rPr>
               <a:t>Fₜ</a:t>
             </a:r>
-            <a:endParaRPr lang="en-US" sz="2000" dirty="0"/>
+            <a:endParaRPr lang="en-US" sz="1900" dirty="0"/>
           </a:p>
           <a:p>
             <a:pPr algn="ctr" indent="0" marL="0">
               <a:buNone/>
             </a:pPr>
             <a:r>
-              <a:rPr lang="en-US" sz="2000" b="1" dirty="0">
+              <a:rPr lang="en-US" sz="1900" b="1" dirty="0">
                 <a:solidFill>
                   <a:srgbClr val="4EA7C4"/>
                 </a:solidFill>
               </a:rPr>
               <a:t>factual state</a:t>
             </a:r>
-            <a:endParaRPr lang="en-US" sz="2000" dirty="0"/>
+            <a:endParaRPr lang="en-US" sz="1900" dirty="0"/>
           </a:p>
         </p:txBody>
       </p:sp>
@@ -8031,8 +8153,8 @@
         </p:nvSpPr>
         <p:spPr>
           <a:xfrm>
-            <a:off x="960120" y="3886200"/>
-            <a:ext cx="2834640" cy="1097280"/>
+            <a:off x="914400" y="3840480"/>
+            <a:ext cx="2743200" cy="1005840"/>
           </a:xfrm>
           <a:prstGeom prst="rect">
             <a:avLst/>
@@ -8056,28 +8178,28 @@
               <a:buNone/>
             </a:pPr>
             <a:r>
-              <a:rPr lang="en-US" sz="2000" b="1" dirty="0">
+              <a:rPr lang="en-US" sz="1900" b="1" dirty="0">
                 <a:solidFill>
                   <a:srgbClr val="6DAA45"/>
                 </a:solidFill>
               </a:rPr>
               <a:t>Vₜ</a:t>
             </a:r>
-            <a:endParaRPr lang="en-US" sz="2000" dirty="0"/>
+            <a:endParaRPr lang="en-US" sz="1900" dirty="0"/>
           </a:p>
           <a:p>
             <a:pPr algn="ctr" indent="0" marL="0">
               <a:buNone/>
             </a:pPr>
             <a:r>
-              <a:rPr lang="en-US" sz="2000" b="1" dirty="0">
+              <a:rPr lang="en-US" sz="1900" b="1" dirty="0">
                 <a:solidFill>
                   <a:srgbClr val="6DAA45"/>
                 </a:solidFill>
               </a:rPr>
               <a:t>value state</a:t>
             </a:r>
-            <a:endParaRPr lang="en-US" sz="2000" dirty="0"/>
+            <a:endParaRPr lang="en-US" sz="1900" dirty="0"/>
           </a:p>
         </p:txBody>
       </p:sp>
@@ -8089,8 +8211,8 @@
         </p:nvSpPr>
         <p:spPr>
           <a:xfrm>
-            <a:off x="8458200" y="2057400"/>
-            <a:ext cx="2834640" cy="1097280"/>
+            <a:off x="8549640" y="1965960"/>
+            <a:ext cx="2743200" cy="1005840"/>
           </a:xfrm>
           <a:prstGeom prst="rect">
             <a:avLst/>
@@ -8114,14 +8236,14 @@
               <a:buNone/>
             </a:pPr>
             <a:r>
-              <a:rPr lang="en-US" sz="2200" b="1" dirty="0">
+              <a:rPr lang="en-US" sz="2100" b="1" dirty="0">
                 <a:solidFill>
                   <a:srgbClr val="4EA7C4"/>
                 </a:solidFill>
               </a:rPr>
               <a:t>Fₜ₊₁</a:t>
             </a:r>
-            <a:endParaRPr lang="en-US" sz="2200" dirty="0"/>
+            <a:endParaRPr lang="en-US" sz="2100" dirty="0"/>
           </a:p>
         </p:txBody>
       </p:sp>
@@ -8133,8 +8255,8 @@
         </p:nvSpPr>
         <p:spPr>
           <a:xfrm>
-            <a:off x="8458200" y="3886200"/>
-            <a:ext cx="2834640" cy="1097280"/>
+            <a:off x="8549640" y="3840480"/>
+            <a:ext cx="2743200" cy="1005840"/>
           </a:xfrm>
           <a:prstGeom prst="rect">
             <a:avLst/>
@@ -8158,33 +8280,77 @@
               <a:buNone/>
             </a:pPr>
             <a:r>
-              <a:rPr lang="en-US" sz="2200" b="1" dirty="0">
+              <a:rPr lang="en-US" sz="2100" b="1" dirty="0">
                 <a:solidFill>
                   <a:srgbClr val="6DAA45"/>
                 </a:solidFill>
               </a:rPr>
               <a:t>Vₜ₊₁</a:t>
             </a:r>
-            <a:endParaRPr lang="en-US" sz="2200" dirty="0"/>
-          </a:p>
-        </p:txBody>
-      </p:sp>
-      <p:sp>
-        <p:nvSpPr>
-          <p:cNvPr id="12" name="Shape 10"/>
-          <p:cNvSpPr/>
-          <p:nvPr/>
-        </p:nvSpPr>
-        <p:spPr>
-          <a:xfrm>
-            <a:off x="3931920" y="2606040"/>
-            <a:ext cx="4343400" cy="0"/>
+            <a:endParaRPr lang="en-US" sz="2100" dirty="0"/>
+          </a:p>
+        </p:txBody>
+      </p:sp>
+      <p:sp>
+        <p:nvSpPr>
+          <p:cNvPr id="12" name="Text 10"/>
+          <p:cNvSpPr/>
+          <p:nvPr/>
+        </p:nvSpPr>
+        <p:spPr>
+          <a:xfrm>
+            <a:off x="4983480" y="2816352"/>
+            <a:ext cx="2240280" cy="658368"/>
+          </a:xfrm>
+          <a:prstGeom prst="rect">
+            <a:avLst/>
+          </a:prstGeom>
+          <a:solidFill>
+            <a:srgbClr val="E8F4F3"/>
+          </a:solidFill>
+          <a:ln w="20320">
+            <a:solidFill>
+              <a:srgbClr val="087C7E"/>
+            </a:solidFill>
+          </a:ln>
+        </p:spPr>
+        <p:txBody>
+          <a:bodyPr wrap="square" lIns="635" tIns="635" rIns="635" bIns="635" rtlCol="0" anchor="ctr">
+            <a:normAutofit/>
+          </a:bodyPr>
+          <a:lstStyle/>
+          <a:p>
+            <a:pPr algn="ctr" indent="0" marL="0">
+              <a:buNone/>
+            </a:pPr>
+            <a:r>
+              <a:rPr lang="en-US" sz="1600" b="1" dirty="0">
+                <a:solidFill>
+                  <a:srgbClr val="087C7E"/>
+                </a:solidFill>
+              </a:rPr>
+              <a:t>coupling</a:t>
+            </a:r>
+            <a:endParaRPr lang="en-US" sz="1600" dirty="0"/>
+          </a:p>
+        </p:txBody>
+      </p:sp>
+      <p:sp>
+        <p:nvSpPr>
+          <p:cNvPr id="13" name="Shape 11"/>
+          <p:cNvSpPr/>
+          <p:nvPr/>
+        </p:nvSpPr>
+        <p:spPr>
+          <a:xfrm>
+            <a:off x="3794760" y="2468880"/>
+            <a:ext cx="1033272" cy="493776"/>
           </a:xfrm>
           <a:prstGeom prst="line">
             <a:avLst/>
           </a:prstGeom>
           <a:noFill/>
-          <a:ln w="31750">
+          <a:ln w="22860">
             <a:solidFill>
               <a:srgbClr val="4EA7C4"/>
             </a:solidFill>
@@ -8196,20 +8362,20 @@
       </p:sp>
       <p:sp>
         <p:nvSpPr>
-          <p:cNvPr id="13" name="Shape 11"/>
-          <p:cNvSpPr/>
-          <p:nvPr/>
-        </p:nvSpPr>
-        <p:spPr>
-          <a:xfrm>
-            <a:off x="3931920" y="4434840"/>
-            <a:ext cx="4343400" cy="0"/>
+          <p:cNvPr id="14" name="Shape 12"/>
+          <p:cNvSpPr/>
+          <p:nvPr/>
+        </p:nvSpPr>
+        <p:spPr>
+          <a:xfrm>
+            <a:off x="3794760" y="4343400"/>
+            <a:ext cx="1033272" cy="-996696"/>
           </a:xfrm>
           <a:prstGeom prst="line">
             <a:avLst/>
           </a:prstGeom>
           <a:noFill/>
-          <a:ln w="31750">
+          <a:ln w="22860">
             <a:solidFill>
               <a:srgbClr val="6DAA45"/>
             </a:solidFill>
@@ -8221,22 +8387,22 @@
       </p:sp>
       <p:sp>
         <p:nvSpPr>
-          <p:cNvPr id="14" name="Shape 12"/>
-          <p:cNvSpPr/>
-          <p:nvPr/>
-        </p:nvSpPr>
-        <p:spPr>
-          <a:xfrm>
-            <a:off x="3749040" y="2697480"/>
-            <a:ext cx="4572000" cy="1463040"/>
+          <p:cNvPr id="15" name="Shape 13"/>
+          <p:cNvSpPr/>
+          <p:nvPr/>
+        </p:nvSpPr>
+        <p:spPr>
+          <a:xfrm>
+            <a:off x="7223760" y="2962656"/>
+            <a:ext cx="1170432" cy="-493776"/>
           </a:xfrm>
           <a:prstGeom prst="line">
             <a:avLst/>
           </a:prstGeom>
           <a:noFill/>
-          <a:ln w="25400">
-            <a:solidFill>
-              <a:srgbClr val="087C7E"/>
+          <a:ln w="22860">
+            <a:solidFill>
+              <a:srgbClr val="4EA7C4"/>
             </a:solidFill>
             <a:prstDash val="solid"/>
             <a:headEnd type="none"/>
@@ -8246,66 +8412,28 @@
       </p:sp>
       <p:sp>
         <p:nvSpPr>
-          <p:cNvPr id="15" name="Shape 13"/>
-          <p:cNvSpPr/>
-          <p:nvPr/>
-        </p:nvSpPr>
-        <p:spPr>
-          <a:xfrm>
-            <a:off x="3749040" y="4160520"/>
-            <a:ext cx="4572000" cy="-1280160"/>
+          <p:cNvPr id="16" name="Shape 14"/>
+          <p:cNvSpPr/>
+          <p:nvPr/>
+        </p:nvSpPr>
+        <p:spPr>
+          <a:xfrm>
+            <a:off x="7223760" y="3346704"/>
+            <a:ext cx="1170432" cy="996696"/>
           </a:xfrm>
           <a:prstGeom prst="line">
             <a:avLst/>
           </a:prstGeom>
           <a:noFill/>
-          <a:ln w="25400">
-            <a:solidFill>
-              <a:srgbClr val="E58A3B"/>
+          <a:ln w="22860">
+            <a:solidFill>
+              <a:srgbClr val="6DAA45"/>
             </a:solidFill>
             <a:prstDash val="solid"/>
             <a:headEnd type="none"/>
             <a:tailEnd type="triangle"/>
           </a:ln>
         </p:spPr>
-      </p:sp>
-      <p:sp>
-        <p:nvSpPr>
-          <p:cNvPr id="16" name="Text 14"/>
-          <p:cNvSpPr/>
-          <p:nvPr/>
-        </p:nvSpPr>
-        <p:spPr>
-          <a:xfrm>
-            <a:off x="5440680" y="3218688"/>
-            <a:ext cx="1371600" cy="365760"/>
-          </a:xfrm>
-          <a:prstGeom prst="rect">
-            <a:avLst/>
-          </a:prstGeom>
-          <a:noFill/>
-          <a:ln/>
-        </p:spPr>
-        <p:txBody>
-          <a:bodyPr wrap="square" lIns="254" tIns="254" rIns="254" bIns="254" rtlCol="0" anchor="ctr">
-            <a:normAutofit/>
-          </a:bodyPr>
-          <a:lstStyle/>
-          <a:p>
-            <a:pPr algn="ctr" indent="0" marL="0">
-              <a:buNone/>
-            </a:pPr>
-            <a:r>
-              <a:rPr lang="en-US" sz="1400" b="1" dirty="0">
-                <a:solidFill>
-                  <a:srgbClr val="087C7E"/>
-                </a:solidFill>
-              </a:rPr>
-              <a:t>coupling</a:t>
-            </a:r>
-            <a:endParaRPr lang="en-US" sz="1400" dirty="0"/>
-          </a:p>
-        </p:txBody>
       </p:sp>
       <p:sp>
         <p:nvSpPr>
@@ -8593,8 +8721,8 @@
         </p:nvSpPr>
         <p:spPr>
           <a:xfrm>
-            <a:off x="4160520" y="1828800"/>
-            <a:ext cx="3840480" cy="822960"/>
+            <a:off x="4251960" y="1783080"/>
+            <a:ext cx="3657600" cy="804672"/>
           </a:xfrm>
           <a:prstGeom prst="rect">
             <a:avLst/>
@@ -8618,14 +8746,14 @@
               <a:buNone/>
             </a:pPr>
             <a:r>
-              <a:rPr lang="en-US" sz="2500" b="1" dirty="0">
+              <a:rPr lang="en-US" sz="2400" b="1" dirty="0">
                 <a:solidFill>
                   <a:srgbClr val="087C7E"/>
                 </a:solidFill>
               </a:rPr>
               <a:t>RATIONALITY</a:t>
             </a:r>
-            <a:endParaRPr lang="en-US" sz="2500" dirty="0"/>
+            <a:endParaRPr lang="en-US" sz="2400" dirty="0"/>
           </a:p>
         </p:txBody>
       </p:sp>
@@ -8637,8 +8765,8 @@
         </p:nvSpPr>
         <p:spPr>
           <a:xfrm>
-            <a:off x="914400" y="3246120"/>
-            <a:ext cx="2286000" cy="914400"/>
+            <a:off x="731520" y="3127248"/>
+            <a:ext cx="2331720" cy="914400"/>
           </a:xfrm>
           <a:prstGeom prst="rect">
             <a:avLst/>
@@ -8662,14 +8790,14 @@
               <a:buNone/>
             </a:pPr>
             <a:r>
-              <a:rPr lang="en-US" sz="1550" b="1" dirty="0">
+              <a:rPr lang="en-US" sz="1480" b="1" dirty="0">
                 <a:solidFill>
                   <a:srgbClr val="4EA7C4"/>
                 </a:solidFill>
               </a:rPr>
               <a:t>follow evidence</a:t>
             </a:r>
-            <a:endParaRPr lang="en-US" sz="1550" dirty="0"/>
+            <a:endParaRPr lang="en-US" sz="1480" dirty="0"/>
           </a:p>
         </p:txBody>
       </p:sp>
@@ -8681,8 +8809,8 @@
         </p:nvSpPr>
         <p:spPr>
           <a:xfrm>
-            <a:off x="3611880" y="3246120"/>
-            <a:ext cx="2286000" cy="914400"/>
+            <a:off x="3429000" y="3127248"/>
+            <a:ext cx="2331720" cy="914400"/>
           </a:xfrm>
           <a:prstGeom prst="rect">
             <a:avLst/>
@@ -8706,14 +8834,14 @@
               <a:buNone/>
             </a:pPr>
             <a:r>
-              <a:rPr lang="en-US" sz="1550" b="1" dirty="0">
+              <a:rPr lang="en-US" sz="1480" b="1" dirty="0">
                 <a:solidFill>
                   <a:srgbClr val="C65C4B"/>
                 </a:solidFill>
               </a:rPr>
               <a:t>avoid contradiction</a:t>
             </a:r>
-            <a:endParaRPr lang="en-US" sz="1550" dirty="0"/>
+            <a:endParaRPr lang="en-US" sz="1480" dirty="0"/>
           </a:p>
         </p:txBody>
       </p:sp>
@@ -8725,8 +8853,8 @@
         </p:nvSpPr>
         <p:spPr>
           <a:xfrm>
-            <a:off x="6309360" y="3246120"/>
-            <a:ext cx="2286000" cy="914400"/>
+            <a:off x="6126480" y="3127248"/>
+            <a:ext cx="2331720" cy="914400"/>
           </a:xfrm>
           <a:prstGeom prst="rect">
             <a:avLst/>
@@ -8750,14 +8878,14 @@
               <a:buNone/>
             </a:pPr>
             <a:r>
-              <a:rPr lang="en-US" sz="1550" b="1" dirty="0">
+              <a:rPr lang="en-US" sz="1480" b="1" dirty="0">
                 <a:solidFill>
                   <a:srgbClr val="6DAA45"/>
                 </a:solidFill>
               </a:rPr>
               <a:t>revise belief</a:t>
             </a:r>
-            <a:endParaRPr lang="en-US" sz="1550" dirty="0"/>
+            <a:endParaRPr lang="en-US" sz="1480" dirty="0"/>
           </a:p>
         </p:txBody>
       </p:sp>
@@ -8769,8 +8897,8 @@
         </p:nvSpPr>
         <p:spPr>
           <a:xfrm>
-            <a:off x="9006840" y="3246120"/>
-            <a:ext cx="2286000" cy="914400"/>
+            <a:off x="8823960" y="3127248"/>
+            <a:ext cx="2331720" cy="914400"/>
           </a:xfrm>
           <a:prstGeom prst="rect">
             <a:avLst/>
@@ -8794,14 +8922,28 @@
               <a:buNone/>
             </a:pPr>
             <a:r>
-              <a:rPr lang="en-US" sz="1550" b="1" dirty="0">
+              <a:rPr lang="en-US" sz="1480" b="1" dirty="0">
                 <a:solidFill>
                   <a:srgbClr val="E58A3B"/>
                 </a:solidFill>
               </a:rPr>
-              <a:t>prefer better explanations</a:t>
-            </a:r>
-            <a:endParaRPr lang="en-US" sz="1550" dirty="0"/>
+              <a:t>prefer better</a:t>
+            </a:r>
+            <a:endParaRPr lang="en-US" sz="1480" dirty="0"/>
+          </a:p>
+          <a:p>
+            <a:pPr algn="ctr" indent="0" marL="0">
+              <a:buNone/>
+            </a:pPr>
+            <a:r>
+              <a:rPr lang="en-US" sz="1480" b="1" dirty="0">
+                <a:solidFill>
+                  <a:srgbClr val="E58A3B"/>
+                </a:solidFill>
+              </a:rPr>
+              <a:t>explanations</a:t>
+            </a:r>
+            <a:endParaRPr lang="en-US" sz="1480" dirty="0"/>
           </a:p>
         </p:txBody>
       </p:sp>
@@ -8813,14 +8955,14 @@
         </p:nvSpPr>
         <p:spPr>
           <a:xfrm>
-            <a:off x="6080760" y="2697480"/>
-            <a:ext cx="-4023360" cy="429768"/>
+            <a:off x="6080760" y="2596896"/>
+            <a:ext cx="-4187952" cy="420624"/>
           </a:xfrm>
           <a:prstGeom prst="line">
             <a:avLst/>
           </a:prstGeom>
           <a:noFill/>
-          <a:ln w="19050">
+          <a:ln w="17145">
             <a:solidFill>
               <a:srgbClr val="6B7A7C"/>
             </a:solidFill>
@@ -8838,14 +8980,14 @@
         </p:nvSpPr>
         <p:spPr>
           <a:xfrm>
-            <a:off x="6080760" y="2697480"/>
-            <a:ext cx="-1325880" cy="429768"/>
+            <a:off x="6080760" y="2596896"/>
+            <a:ext cx="-1490472" cy="420624"/>
           </a:xfrm>
           <a:prstGeom prst="line">
             <a:avLst/>
           </a:prstGeom>
           <a:noFill/>
-          <a:ln w="19050">
+          <a:ln w="17145">
             <a:solidFill>
               <a:srgbClr val="6B7A7C"/>
             </a:solidFill>
@@ -8863,14 +9005,14 @@
         </p:nvSpPr>
         <p:spPr>
           <a:xfrm>
-            <a:off x="6080760" y="2697480"/>
-            <a:ext cx="1371600" cy="429768"/>
+            <a:off x="6080760" y="2596896"/>
+            <a:ext cx="1207008" cy="420624"/>
           </a:xfrm>
           <a:prstGeom prst="line">
             <a:avLst/>
           </a:prstGeom>
           <a:noFill/>
-          <a:ln w="19050">
+          <a:ln w="17145">
             <a:solidFill>
               <a:srgbClr val="6B7A7C"/>
             </a:solidFill>
@@ -8888,14 +9030,14 @@
         </p:nvSpPr>
         <p:spPr>
           <a:xfrm>
-            <a:off x="6080760" y="2697480"/>
-            <a:ext cx="4069080" cy="429768"/>
+            <a:off x="6080760" y="2596896"/>
+            <a:ext cx="3904488" cy="420624"/>
           </a:xfrm>
           <a:prstGeom prst="line">
             <a:avLst/>
           </a:prstGeom>
           <a:noFill/>
-          <a:ln w="19050">
+          <a:ln w="17145">
             <a:solidFill>
               <a:srgbClr val="6B7A7C"/>
             </a:solidFill>
@@ -8913,8 +9055,8 @@
         </p:nvSpPr>
         <p:spPr>
           <a:xfrm>
-            <a:off x="1051560" y="4754880"/>
-            <a:ext cx="10058400" cy="640080"/>
+            <a:off x="1051560" y="4617720"/>
+            <a:ext cx="10058400" cy="566928"/>
           </a:xfrm>
           <a:prstGeom prst="rect">
             <a:avLst/>
@@ -8932,14 +9074,14 @@
               <a:buNone/>
             </a:pPr>
             <a:r>
-              <a:rPr lang="en-US" sz="1800" b="1" dirty="0">
+              <a:rPr lang="en-US" sz="1600" b="1" dirty="0">
                 <a:solidFill>
                   <a:srgbClr val="304245"/>
                 </a:solidFill>
               </a:rPr>
-              <a:t>These are standards for how one ought to reason—not merely descriptions of what brains happen to do.</a:t>
-            </a:r>
-            <a:endParaRPr lang="en-US" sz="1800" dirty="0"/>
+              <a:t>These are standards for how one ought to reason — not merely descriptions of what brains happen to do.</a:t>
+            </a:r>
+            <a:endParaRPr lang="en-US" sz="1600" dirty="0"/>
           </a:p>
         </p:txBody>
       </p:sp>
@@ -8981,7 +9123,7 @@
                   <a:srgbClr val="FFFFFF"/>
                 </a:solidFill>
               </a:rPr>
-              <a:t>Remove every normative standard and “rationality” collapses into causal psychology.</a:t>
+              <a:t>Strip out every norm and rationality collapses into causal psychology.</a:t>
             </a:r>
             <a:endParaRPr lang="en-US" sz="1620" dirty="0"/>
           </a:p>
@@ -9229,8 +9371,8 @@
         </p:nvSpPr>
         <p:spPr>
           <a:xfrm>
-            <a:off x="914400" y="1828800"/>
-            <a:ext cx="2834640" cy="1051560"/>
+            <a:off x="868680" y="1828800"/>
+            <a:ext cx="2880360" cy="1005840"/>
           </a:xfrm>
           <a:prstGeom prst="rect">
             <a:avLst/>
@@ -9273,8 +9415,8 @@
         </p:nvSpPr>
         <p:spPr>
           <a:xfrm>
-            <a:off x="4663440" y="1828800"/>
-            <a:ext cx="2834640" cy="1051560"/>
+            <a:off x="4617720" y="1828800"/>
+            <a:ext cx="2971800" cy="1005840"/>
           </a:xfrm>
           <a:prstGeom prst="rect">
             <a:avLst/>
@@ -9298,14 +9440,28 @@
               <a:buNone/>
             </a:pPr>
             <a:r>
-              <a:rPr lang="en-US" sz="2800" b="1" dirty="0">
+              <a:rPr lang="en-US" sz="1850" b="1" dirty="0">
                 <a:solidFill>
                   <a:srgbClr val="E58A3B"/>
                 </a:solidFill>
               </a:rPr>
-              <a:t>F ⟂ V ?</a:t>
-            </a:r>
-            <a:endParaRPr lang="en-US" sz="2800" dirty="0"/>
+              <a:t>F and V</a:t>
+            </a:r>
+            <a:endParaRPr lang="en-US" sz="1850" dirty="0"/>
+          </a:p>
+          <a:p>
+            <a:pPr algn="ctr" indent="0" marL="0">
+              <a:buNone/>
+            </a:pPr>
+            <a:r>
+              <a:rPr lang="en-US" sz="1850" b="1" dirty="0">
+                <a:solidFill>
+                  <a:srgbClr val="E58A3B"/>
+                </a:solidFill>
+              </a:rPr>
+              <a:t>are not independent</a:t>
+            </a:r>
+            <a:endParaRPr lang="en-US" sz="1850" dirty="0"/>
           </a:p>
         </p:txBody>
       </p:sp>
@@ -9317,8 +9473,8 @@
         </p:nvSpPr>
         <p:spPr>
           <a:xfrm>
-            <a:off x="8412480" y="1828800"/>
-            <a:ext cx="2834640" cy="1051560"/>
+            <a:off x="8458200" y="1828800"/>
+            <a:ext cx="2880360" cy="1005840"/>
           </a:xfrm>
           <a:prstGeom prst="rect">
             <a:avLst/>
@@ -9342,28 +9498,28 @@
               <a:buNone/>
             </a:pPr>
             <a:r>
-              <a:rPr lang="en-US" sz="2100" b="1" dirty="0">
+              <a:rPr lang="en-US" sz="2000" b="1" dirty="0">
                 <a:solidFill>
                   <a:srgbClr val="087C7E"/>
                 </a:solidFill>
               </a:rPr>
               <a:t>(Fₜ,Vₜ) →</a:t>
             </a:r>
-            <a:endParaRPr lang="en-US" sz="2100" dirty="0"/>
+            <a:endParaRPr lang="en-US" sz="2000" dirty="0"/>
           </a:p>
           <a:p>
             <a:pPr algn="ctr" indent="0" marL="0">
               <a:buNone/>
             </a:pPr>
             <a:r>
-              <a:rPr lang="en-US" sz="2100" b="1" dirty="0">
+              <a:rPr lang="en-US" sz="2000" b="1" dirty="0">
                 <a:solidFill>
                   <a:srgbClr val="087C7E"/>
                 </a:solidFill>
               </a:rPr>
               <a:t>(Fₜ₊₁,Vₜ₊₁)</a:t>
             </a:r>
-            <a:endParaRPr lang="en-US" sz="2100" dirty="0"/>
+            <a:endParaRPr lang="en-US" sz="2000" dirty="0"/>
           </a:p>
         </p:txBody>
       </p:sp>
@@ -9437,7 +9593,7 @@
                   <a:srgbClr val="E58A3B"/>
                 </a:solidFill>
               </a:rPr>
-              <a:t>2. Not always separable</a:t>
+              <a:t>2. Not sealed off</a:t>
             </a:r>
             <a:endParaRPr lang="en-US" sz="2000" dirty="0"/>
           </a:p>
@@ -9514,14 +9670,14 @@
               <a:buNone/>
             </a:pPr>
             <a:r>
-              <a:rPr lang="en-US" sz="1620" b="1" dirty="0">
+              <a:rPr lang="en-US" sz="1420" b="1" dirty="0">
                 <a:solidFill>
                   <a:srgbClr val="FFFFFF"/>
                 </a:solidFill>
               </a:rPr>
-              <a:t>Putnam’s point is not that facts are values. It is that our best descriptions and our best evaluations often cannot be cleanly pulled apart.</a:t>
-            </a:r>
-            <a:endParaRPr lang="en-US" sz="1620" dirty="0"/>
+              <a:t>Putnam’s point is not that facts are values. It is that our best descriptions and evaluations often cannot be cleanly pulled apart.</a:t>
+            </a:r>
+            <a:endParaRPr lang="en-US" sz="1420" dirty="0"/>
           </a:p>
         </p:txBody>
       </p:sp>
@@ -9767,12 +9923,12 @@
         </p:nvSpPr>
         <p:spPr>
           <a:xfrm>
-            <a:off x="822960" y="1965960"/>
-            <a:ext cx="4937760" cy="2971800"/>
+            <a:off x="822960" y="1874520"/>
+            <a:ext cx="4983480" cy="3063240"/>
           </a:xfrm>
           <a:prstGeom prst="roundRect">
             <a:avLst>
-              <a:gd name="adj" fmla="val 2462"/>
+              <a:gd name="adj" fmla="val 2388"/>
             </a:avLst>
           </a:prstGeom>
           <a:solidFill>
@@ -9794,8 +9950,8 @@
         </p:nvSpPr>
         <p:spPr>
           <a:xfrm>
-            <a:off x="822960" y="1965960"/>
-            <a:ext cx="73152" cy="2971800"/>
+            <a:off x="822960" y="1874520"/>
+            <a:ext cx="73152" cy="3063240"/>
           </a:xfrm>
           <a:prstGeom prst="rect">
             <a:avLst/>
@@ -9819,8 +9975,8 @@
         </p:nvSpPr>
         <p:spPr>
           <a:xfrm>
-            <a:off x="1078992" y="2167128"/>
-            <a:ext cx="4480560" cy="329184"/>
+            <a:off x="1078992" y="2075688"/>
+            <a:ext cx="4526280" cy="329184"/>
           </a:xfrm>
           <a:prstGeom prst="rect">
             <a:avLst/>
@@ -9857,8 +10013,8 @@
         </p:nvSpPr>
         <p:spPr>
           <a:xfrm>
-            <a:off x="1078992" y="2624328"/>
-            <a:ext cx="4434840" cy="2148840"/>
+            <a:off x="1078992" y="2532888"/>
+            <a:ext cx="4480560" cy="2240280"/>
           </a:xfrm>
           <a:prstGeom prst="rect">
             <a:avLst/>
@@ -9876,56 +10032,56 @@
               <a:buNone/>
             </a:pPr>
             <a:r>
-              <a:rPr lang="en-US" sz="1650" dirty="0">
+              <a:rPr lang="en-US" sz="1700" dirty="0">
                 <a:solidFill>
                   <a:srgbClr val="304245"/>
                 </a:solidFill>
               </a:rPr>
               <a:t>observation</a:t>
             </a:r>
-            <a:endParaRPr lang="en-US" sz="1650" dirty="0"/>
+            <a:endParaRPr lang="en-US" sz="1700" dirty="0"/>
           </a:p>
           <a:p>
             <a:pPr indent="0" marL="0">
               <a:buNone/>
             </a:pPr>
             <a:r>
-              <a:rPr lang="en-US" sz="1650" dirty="0">
+              <a:rPr lang="en-US" sz="1700" dirty="0">
                 <a:solidFill>
                   <a:srgbClr val="304245"/>
                 </a:solidFill>
               </a:rPr>
               <a:t>measurement</a:t>
             </a:r>
-            <a:endParaRPr lang="en-US" sz="1650" dirty="0"/>
+            <a:endParaRPr lang="en-US" sz="1700" dirty="0"/>
           </a:p>
           <a:p>
             <a:pPr indent="0" marL="0">
               <a:buNone/>
             </a:pPr>
             <a:r>
-              <a:rPr lang="en-US" sz="1650" dirty="0">
+              <a:rPr lang="en-US" sz="1700" dirty="0">
                 <a:solidFill>
                   <a:srgbClr val="304245"/>
                 </a:solidFill>
               </a:rPr>
               <a:t>empirical claims</a:t>
             </a:r>
-            <a:endParaRPr lang="en-US" sz="1650" dirty="0"/>
+            <a:endParaRPr lang="en-US" sz="1700" dirty="0"/>
           </a:p>
           <a:p>
             <a:pPr indent="0" marL="0">
               <a:buNone/>
             </a:pPr>
             <a:r>
-              <a:rPr lang="en-US" sz="1650" dirty="0">
+              <a:rPr lang="en-US" sz="1700" dirty="0">
                 <a:solidFill>
                   <a:srgbClr val="304245"/>
                 </a:solidFill>
               </a:rPr>
               <a:t>theory</a:t>
             </a:r>
-            <a:endParaRPr lang="en-US" sz="1650" dirty="0"/>
+            <a:endParaRPr lang="en-US" sz="1700" dirty="0"/>
           </a:p>
         </p:txBody>
       </p:sp>
@@ -9937,12 +10093,12 @@
         </p:nvSpPr>
         <p:spPr>
           <a:xfrm>
-            <a:off x="6400800" y="1965960"/>
-            <a:ext cx="4937760" cy="2971800"/>
+            <a:off x="6355080" y="1874520"/>
+            <a:ext cx="4983480" cy="3063240"/>
           </a:xfrm>
           <a:prstGeom prst="roundRect">
             <a:avLst>
-              <a:gd name="adj" fmla="val 2462"/>
+              <a:gd name="adj" fmla="val 2388"/>
             </a:avLst>
           </a:prstGeom>
           <a:solidFill>
@@ -9964,8 +10120,8 @@
         </p:nvSpPr>
         <p:spPr>
           <a:xfrm>
-            <a:off x="6400800" y="1965960"/>
-            <a:ext cx="73152" cy="2971800"/>
+            <a:off x="6355080" y="1874520"/>
+            <a:ext cx="73152" cy="3063240"/>
           </a:xfrm>
           <a:prstGeom prst="rect">
             <a:avLst/>
@@ -9989,8 +10145,8 @@
         </p:nvSpPr>
         <p:spPr>
           <a:xfrm>
-            <a:off x="6656832" y="2167128"/>
-            <a:ext cx="4480560" cy="329184"/>
+            <a:off x="6611112" y="2075688"/>
+            <a:ext cx="4526280" cy="329184"/>
           </a:xfrm>
           <a:prstGeom prst="rect">
             <a:avLst/>
@@ -10027,8 +10183,8 @@
         </p:nvSpPr>
         <p:spPr>
           <a:xfrm>
-            <a:off x="6656832" y="2624328"/>
-            <a:ext cx="4434840" cy="2148840"/>
+            <a:off x="6611112" y="2532888"/>
+            <a:ext cx="4480560" cy="2240280"/>
           </a:xfrm>
           <a:prstGeom prst="rect">
             <a:avLst/>
@@ -10046,56 +10202,56 @@
               <a:buNone/>
             </a:pPr>
             <a:r>
-              <a:rPr lang="en-US" sz="1650" dirty="0">
+              <a:rPr lang="en-US" sz="1700" dirty="0">
                 <a:solidFill>
                   <a:srgbClr val="304245"/>
                 </a:solidFill>
               </a:rPr>
               <a:t>good / bad</a:t>
             </a:r>
-            <a:endParaRPr lang="en-US" sz="1650" dirty="0"/>
+            <a:endParaRPr lang="en-US" sz="1700" dirty="0"/>
           </a:p>
           <a:p>
             <a:pPr indent="0" marL="0">
               <a:buNone/>
             </a:pPr>
             <a:r>
-              <a:rPr lang="en-US" sz="1650" dirty="0">
+              <a:rPr lang="en-US" sz="1700" dirty="0">
                 <a:solidFill>
                   <a:srgbClr val="304245"/>
                 </a:solidFill>
               </a:rPr>
               <a:t>right / wrong</a:t>
             </a:r>
-            <a:endParaRPr lang="en-US" sz="1650" dirty="0"/>
+            <a:endParaRPr lang="en-US" sz="1700" dirty="0"/>
           </a:p>
           <a:p>
             <a:pPr indent="0" marL="0">
               <a:buNone/>
             </a:pPr>
             <a:r>
-              <a:rPr lang="en-US" sz="1650" dirty="0">
+              <a:rPr lang="en-US" sz="1700" dirty="0">
                 <a:solidFill>
                   <a:srgbClr val="304245"/>
                 </a:solidFill>
               </a:rPr>
               <a:t>rational / irrational</a:t>
             </a:r>
-            <a:endParaRPr lang="en-US" sz="1650" dirty="0"/>
+            <a:endParaRPr lang="en-US" sz="1700" dirty="0"/>
           </a:p>
           <a:p>
             <a:pPr indent="0" marL="0">
               <a:buNone/>
             </a:pPr>
             <a:r>
-              <a:rPr lang="en-US" sz="1650" dirty="0">
+              <a:rPr lang="en-US" sz="1700" dirty="0">
                 <a:solidFill>
                   <a:srgbClr val="304245"/>
                 </a:solidFill>
               </a:rPr>
               <a:t>ought</a:t>
             </a:r>
-            <a:endParaRPr lang="en-US" sz="1650" dirty="0"/>
+            <a:endParaRPr lang="en-US" sz="1700" dirty="0"/>
           </a:p>
         </p:txBody>
       </p:sp>
@@ -10107,8 +10263,8 @@
         </p:nvSpPr>
         <p:spPr>
           <a:xfrm>
-            <a:off x="4663440" y="5193792"/>
-            <a:ext cx="2880360" cy="502920"/>
+            <a:off x="4343400" y="5010912"/>
+            <a:ext cx="3520440" cy="658368"/>
           </a:xfrm>
           <a:prstGeom prst="rect">
             <a:avLst/>
@@ -10126,14 +10282,14 @@
               <a:buNone/>
             </a:pPr>
             <a:r>
-              <a:rPr lang="en-US" sz="2800" b="1" dirty="0">
+              <a:rPr lang="en-US" sz="3200" b="1" dirty="0">
                 <a:solidFill>
                   <a:srgbClr val="142326"/>
                 </a:solidFill>
               </a:rPr>
               <a:t>F ∩ V = ∅</a:t>
             </a:r>
-            <a:endParaRPr lang="en-US" sz="2800" dirty="0"/>
+            <a:endParaRPr lang="en-US" sz="3200" dirty="0"/>
           </a:p>
         </p:txBody>
       </p:sp>
@@ -10423,8 +10579,8 @@
         </p:nvSpPr>
         <p:spPr>
           <a:xfrm>
-            <a:off x="1051560" y="2286000"/>
-            <a:ext cx="2880360" cy="1143000"/>
+            <a:off x="868680" y="2148840"/>
+            <a:ext cx="3108960" cy="1207008"/>
           </a:xfrm>
           <a:prstGeom prst="rect">
             <a:avLst/>
@@ -10481,8 +10637,8 @@
         </p:nvSpPr>
         <p:spPr>
           <a:xfrm>
-            <a:off x="8229600" y="2286000"/>
-            <a:ext cx="2880360" cy="1143000"/>
+            <a:off x="8183880" y="2148840"/>
+            <a:ext cx="3108960" cy="1207008"/>
           </a:xfrm>
           <a:prstGeom prst="rect">
             <a:avLst/>
@@ -10539,8 +10695,8 @@
         </p:nvSpPr>
         <p:spPr>
           <a:xfrm>
-            <a:off x="4114800" y="2633472"/>
-            <a:ext cx="3977640" cy="0"/>
+            <a:off x="4160520" y="2542032"/>
+            <a:ext cx="3840480" cy="0"/>
           </a:xfrm>
           <a:prstGeom prst="line">
             <a:avLst/>
@@ -10564,8 +10720,8 @@
         </p:nvSpPr>
         <p:spPr>
           <a:xfrm>
-            <a:off x="8092440" y="3127248"/>
-            <a:ext cx="-3977640" cy="0"/>
+            <a:off x="8001000" y="2999232"/>
+            <a:ext cx="-3840480" cy="0"/>
           </a:xfrm>
           <a:prstGeom prst="line">
             <a:avLst/>
@@ -10589,8 +10745,8 @@
         </p:nvSpPr>
         <p:spPr>
           <a:xfrm>
-            <a:off x="914400" y="4069080"/>
-            <a:ext cx="4663440" cy="566928"/>
+            <a:off x="960120" y="3822192"/>
+            <a:ext cx="4206240" cy="658368"/>
           </a:xfrm>
           <a:prstGeom prst="rect">
             <a:avLst/>
@@ -10604,19 +10760,33 @@
           </a:bodyPr>
           <a:lstStyle/>
           <a:p>
-            <a:pPr algn="l" indent="0" marL="0">
-              <a:buNone/>
-            </a:pPr>
-            <a:r>
-              <a:rPr lang="en-US" sz="1600" dirty="0">
+            <a:pPr algn="ctr" indent="0" marL="0">
+              <a:buNone/>
+            </a:pPr>
+            <a:r>
+              <a:rPr lang="en-US" sz="1600" b="1" dirty="0">
                 <a:solidFill>
                   <a:srgbClr val="304245"/>
                 </a:solidFill>
               </a:rPr>
-              <a:t>Values select what gets built, funded, measured, defended.</a:t>
+              <a:t>Values select what gets</a:t>
             </a:r>
             <a:endParaRPr lang="en-US" sz="1600" dirty="0"/>
           </a:p>
+          <a:p>
+            <a:pPr algn="ctr" indent="0" marL="0">
+              <a:buNone/>
+            </a:pPr>
+            <a:r>
+              <a:rPr lang="en-US" sz="1600" b="1" dirty="0">
+                <a:solidFill>
+                  <a:srgbClr val="304245"/>
+                </a:solidFill>
+              </a:rPr>
+              <a:t>built, funded, measured.</a:t>
+            </a:r>
+            <a:endParaRPr lang="en-US" sz="1600" dirty="0"/>
+          </a:p>
         </p:txBody>
       </p:sp>
       <p:sp>
@@ -10627,8 +10797,8 @@
         </p:nvSpPr>
         <p:spPr>
           <a:xfrm>
-            <a:off x="6537960" y="4069080"/>
-            <a:ext cx="4663440" cy="566928"/>
+            <a:off x="7040880" y="3822192"/>
+            <a:ext cx="4206240" cy="658368"/>
           </a:xfrm>
           <a:prstGeom prst="rect">
             <a:avLst/>
@@ -10642,19 +10812,33 @@
           </a:bodyPr>
           <a:lstStyle/>
           <a:p>
-            <a:pPr algn="l" indent="0" marL="0">
-              <a:buNone/>
-            </a:pPr>
-            <a:r>
-              <a:rPr lang="en-US" sz="1600" dirty="0">
+            <a:pPr algn="ctr" indent="0" marL="0">
+              <a:buNone/>
+            </a:pPr>
+            <a:r>
+              <a:rPr lang="en-US" sz="1600" b="1" dirty="0">
                 <a:solidFill>
                   <a:srgbClr val="304245"/>
                 </a:solidFill>
               </a:rPr>
-              <a:t>Facts and consequences reshape what people value next.</a:t>
+              <a:t>Facts and consequences</a:t>
             </a:r>
             <a:endParaRPr lang="en-US" sz="1600" dirty="0"/>
           </a:p>
+          <a:p>
+            <a:pPr algn="ctr" indent="0" marL="0">
+              <a:buNone/>
+            </a:pPr>
+            <a:r>
+              <a:rPr lang="en-US" sz="1600" b="1" dirty="0">
+                <a:solidFill>
+                  <a:srgbClr val="304245"/>
+                </a:solidFill>
+              </a:rPr>
+              <a:t>reshape values next.</a:t>
+            </a:r>
+            <a:endParaRPr lang="en-US" sz="1600" dirty="0"/>
+          </a:p>
         </p:txBody>
       </p:sp>
       <p:sp>
@@ -10665,8 +10849,8 @@
         </p:nvSpPr>
         <p:spPr>
           <a:xfrm>
-            <a:off x="1097280" y="4892040"/>
-            <a:ext cx="1234440" cy="402336"/>
+            <a:off x="914400" y="4773168"/>
+            <a:ext cx="1188720" cy="402336"/>
           </a:xfrm>
           <a:prstGeom prst="rect">
             <a:avLst/>
@@ -10709,8 +10893,8 @@
         </p:nvSpPr>
         <p:spPr>
           <a:xfrm>
-            <a:off x="2514600" y="4892040"/>
-            <a:ext cx="1234440" cy="402336"/>
+            <a:off x="2304288" y="4773168"/>
+            <a:ext cx="1188720" cy="402336"/>
           </a:xfrm>
           <a:prstGeom prst="rect">
             <a:avLst/>
@@ -10739,7 +10923,7 @@
                   <a:srgbClr val="FFFFFF"/>
                 </a:solidFill>
               </a:rPr>
-              <a:t>research agenda</a:t>
+              <a:t>research</a:t>
             </a:r>
             <a:endParaRPr lang="en-US" sz="1150" dirty="0"/>
           </a:p>
@@ -10753,8 +10937,8 @@
         </p:nvSpPr>
         <p:spPr>
           <a:xfrm>
-            <a:off x="3931920" y="4892040"/>
-            <a:ext cx="1234440" cy="402336"/>
+            <a:off x="3694176" y="4773168"/>
+            <a:ext cx="1188720" cy="402336"/>
           </a:xfrm>
           <a:prstGeom prst="rect">
             <a:avLst/>
@@ -10783,7 +10967,7 @@
                   <a:srgbClr val="FFFFFF"/>
                 </a:solidFill>
               </a:rPr>
-              <a:t>design choice</a:t>
+              <a:t>design</a:t>
             </a:r>
             <a:endParaRPr lang="en-US" sz="1150" dirty="0"/>
           </a:p>
@@ -10827,7 +11011,7 @@
                   <a:srgbClr val="FFFFFF"/>
                 </a:solidFill>
               </a:rPr>
-              <a:t>V → F and F → V: interaction is real. But interaction alone is not yet Putnam.</a:t>
+              <a:t>Interaction is real. But interaction alone is not yet Putnam.</a:t>
             </a:r>
             <a:endParaRPr lang="en-US" sz="1620" dirty="0"/>
           </a:p>
@@ -11075,8 +11259,8 @@
         </p:nvSpPr>
         <p:spPr>
           <a:xfrm>
-            <a:off x="1143000" y="2240280"/>
-            <a:ext cx="2926080" cy="914400"/>
+            <a:off x="1051560" y="2148840"/>
+            <a:ext cx="2971800" cy="868680"/>
           </a:xfrm>
           <a:prstGeom prst="rect">
             <a:avLst/>
@@ -11119,8 +11303,8 @@
         </p:nvSpPr>
         <p:spPr>
           <a:xfrm>
-            <a:off x="8138160" y="2240280"/>
-            <a:ext cx="2926080" cy="914400"/>
+            <a:off x="8183880" y="2148840"/>
+            <a:ext cx="2971800" cy="868680"/>
           </a:xfrm>
           <a:prstGeom prst="rect">
             <a:avLst/>
@@ -11163,14 +11347,14 @@
         </p:nvSpPr>
         <p:spPr>
           <a:xfrm>
-            <a:off x="4251960" y="2542032"/>
-            <a:ext cx="3703320" cy="0"/>
+            <a:off x="4160520" y="2423160"/>
+            <a:ext cx="3840480" cy="0"/>
           </a:xfrm>
           <a:prstGeom prst="line">
             <a:avLst/>
           </a:prstGeom>
           <a:noFill/>
-          <a:ln w="31750">
+          <a:ln w="30480">
             <a:solidFill>
               <a:srgbClr val="4EA7C4"/>
             </a:solidFill>
@@ -11188,14 +11372,14 @@
         </p:nvSpPr>
         <p:spPr>
           <a:xfrm>
-            <a:off x="7955280" y="2999232"/>
-            <a:ext cx="-3703320" cy="0"/>
+            <a:off x="8001000" y="2743200"/>
+            <a:ext cx="-3840480" cy="0"/>
           </a:xfrm>
           <a:prstGeom prst="line">
             <a:avLst/>
           </a:prstGeom>
           <a:noFill/>
-          <a:ln w="31750">
+          <a:ln w="30480">
             <a:solidFill>
               <a:srgbClr val="E58A3B"/>
             </a:solidFill>
@@ -11213,8 +11397,8 @@
         </p:nvSpPr>
         <p:spPr>
           <a:xfrm>
-            <a:off x="1143000" y="3749040"/>
-            <a:ext cx="2926080" cy="411480"/>
+            <a:off x="1051560" y="3566160"/>
+            <a:ext cx="2971800" cy="411480"/>
           </a:xfrm>
           <a:prstGeom prst="rect">
             <a:avLst/>
@@ -11232,14 +11416,14 @@
               <a:buNone/>
             </a:pPr>
             <a:r>
-              <a:rPr lang="en-US" sz="1900" b="1" dirty="0">
+              <a:rPr lang="en-US" sz="1800" b="1" dirty="0">
                 <a:solidFill>
                   <a:srgbClr val="142326"/>
                 </a:solidFill>
               </a:rPr>
               <a:t>They interact.</a:t>
             </a:r>
-            <a:endParaRPr lang="en-US" sz="1900" dirty="0"/>
+            <a:endParaRPr lang="en-US" sz="1800" dirty="0"/>
           </a:p>
         </p:txBody>
       </p:sp>
@@ -11251,8 +11435,8 @@
         </p:nvSpPr>
         <p:spPr>
           <a:xfrm>
-            <a:off x="7726680" y="3749040"/>
-            <a:ext cx="3749040" cy="411480"/>
+            <a:off x="7955280" y="3566160"/>
+            <a:ext cx="3429000" cy="411480"/>
           </a:xfrm>
           <a:prstGeom prst="rect">
             <a:avLst/>
@@ -11270,20 +11454,134 @@
               <a:buNone/>
             </a:pPr>
             <a:r>
-              <a:rPr lang="en-US" sz="1900" b="1" dirty="0">
+              <a:rPr lang="en-US" sz="1800" b="1" dirty="0">
                 <a:solidFill>
                   <a:srgbClr val="142326"/>
                 </a:solidFill>
               </a:rPr>
-              <a:t>They are not the same thing.</a:t>
-            </a:r>
-            <a:endParaRPr lang="en-US" sz="1900" dirty="0"/>
+              <a:t>They remain distinct.</a:t>
+            </a:r>
+            <a:endParaRPr lang="en-US" sz="1800" dirty="0"/>
           </a:p>
         </p:txBody>
       </p:sp>
       <p:sp>
         <p:nvSpPr>
           <p:cNvPr id="14" name="Text 12"/>
+          <p:cNvSpPr/>
+          <p:nvPr/>
+        </p:nvSpPr>
+        <p:spPr>
+          <a:xfrm>
+            <a:off x="1920240" y="4617720"/>
+            <a:ext cx="2468880" cy="411480"/>
+          </a:xfrm>
+          <a:prstGeom prst="rect">
+            <a:avLst/>
+          </a:prstGeom>
+          <a:noFill/>
+          <a:ln/>
+        </p:spPr>
+        <p:txBody>
+          <a:bodyPr wrap="square" lIns="254" tIns="254" rIns="254" bIns="254" rtlCol="0" anchor="ctr">
+            <a:normAutofit/>
+          </a:bodyPr>
+          <a:lstStyle/>
+          <a:p>
+            <a:pPr algn="ctr" indent="0" marL="0">
+              <a:buNone/>
+            </a:pPr>
+            <a:r>
+              <a:rPr lang="en-US" sz="1800" b="1" dirty="0">
+                <a:solidFill>
+                  <a:srgbClr val="087C7E"/>
+                </a:solidFill>
+              </a:rPr>
+              <a:t>V → F and F → V</a:t>
+            </a:r>
+            <a:endParaRPr lang="en-US" sz="1800" dirty="0"/>
+          </a:p>
+        </p:txBody>
+      </p:sp>
+      <p:sp>
+        <p:nvSpPr>
+          <p:cNvPr id="15" name="Text 13"/>
+          <p:cNvSpPr/>
+          <p:nvPr/>
+        </p:nvSpPr>
+        <p:spPr>
+          <a:xfrm>
+            <a:off x="5577840" y="4480560"/>
+            <a:ext cx="1005840" cy="548640"/>
+          </a:xfrm>
+          <a:prstGeom prst="rect">
+            <a:avLst/>
+          </a:prstGeom>
+          <a:noFill/>
+          <a:ln/>
+        </p:spPr>
+        <p:txBody>
+          <a:bodyPr wrap="square" lIns="254" tIns="254" rIns="254" bIns="254" rtlCol="0" anchor="ctr">
+            <a:normAutofit/>
+          </a:bodyPr>
+          <a:lstStyle/>
+          <a:p>
+            <a:pPr algn="ctr" indent="0" marL="0">
+              <a:buNone/>
+            </a:pPr>
+            <a:r>
+              <a:rPr lang="en-US" sz="3000" b="1" dirty="0">
+                <a:solidFill>
+                  <a:srgbClr val="C65C4B"/>
+                </a:solidFill>
+              </a:rPr>
+              <a:t>≠</a:t>
+            </a:r>
+            <a:endParaRPr lang="en-US" sz="3000" dirty="0"/>
+          </a:p>
+        </p:txBody>
+      </p:sp>
+      <p:sp>
+        <p:nvSpPr>
+          <p:cNvPr id="16" name="Text 14"/>
+          <p:cNvSpPr/>
+          <p:nvPr/>
+        </p:nvSpPr>
+        <p:spPr>
+          <a:xfrm>
+            <a:off x="7315200" y="4617720"/>
+            <a:ext cx="3017520" cy="411480"/>
+          </a:xfrm>
+          <a:prstGeom prst="rect">
+            <a:avLst/>
+          </a:prstGeom>
+          <a:noFill/>
+          <a:ln/>
+        </p:spPr>
+        <p:txBody>
+          <a:bodyPr wrap="square" lIns="254" tIns="254" rIns="254" bIns="254" rtlCol="0" anchor="ctr">
+            <a:normAutofit/>
+          </a:bodyPr>
+          <a:lstStyle/>
+          <a:p>
+            <a:pPr algn="ctr" indent="0" marL="0">
+              <a:buNone/>
+            </a:pPr>
+            <a:r>
+              <a:rPr lang="en-US" sz="1700" b="1" dirty="0">
+                <a:solidFill>
+                  <a:srgbClr val="C65C4B"/>
+                </a:solidFill>
+              </a:rPr>
+              <a:t>conceptual inseparability</a:t>
+            </a:r>
+            <a:endParaRPr lang="en-US" sz="1700" dirty="0"/>
+          </a:p>
+        </p:txBody>
+      </p:sp>
+      <p:sp>
+        <p:nvSpPr>
+          <p:cNvPr id="17" name="Text 15"/>
           <p:cNvSpPr/>
           <p:nvPr/>
         </p:nvSpPr>
@@ -11319,7 +11617,7 @@
                   <a:srgbClr val="FFFFFF"/>
                 </a:solidFill>
               </a:rPr>
-              <a:t>V → F and F → V  ≠  conceptual inseparability</a:t>
+              <a:t>This slide blocks the sloppy version of the argument.</a:t>
             </a:r>
             <a:endParaRPr lang="en-US" sz="1620" dirty="0"/>
           </a:p>
@@ -11553,7 +11851,7 @@
                   <a:srgbClr val="6B7A7C"/>
                 </a:solidFill>
               </a:rPr>
-              <a:t>Putnam’s pressure point is not causal. It is conceptual.</a:t>
+              <a:t>Putnam’s pressure point is conceptual, not merely causal.</a:t>
             </a:r>
             <a:endParaRPr lang="en-US" sz="1450" dirty="0"/>
           </a:p>
@@ -11567,15 +11865,15 @@
         </p:nvSpPr>
         <p:spPr>
           <a:xfrm>
-            <a:off x="2926080" y="1901952"/>
-            <a:ext cx="3154680" cy="2743200"/>
+            <a:off x="2606040" y="1828800"/>
+            <a:ext cx="3520440" cy="2926080"/>
           </a:xfrm>
           <a:prstGeom prst="ellipse">
             <a:avLst/>
           </a:prstGeom>
           <a:solidFill>
             <a:srgbClr val="EAF3F7">
-              <a:alpha val="95000"/>
+              <a:alpha val="94000"/>
             </a:srgbClr>
           </a:solidFill>
           <a:ln w="25400">
@@ -11594,15 +11892,15 @@
         </p:nvSpPr>
         <p:spPr>
           <a:xfrm>
-            <a:off x="5897880" y="1901952"/>
-            <a:ext cx="3154680" cy="2743200"/>
+            <a:off x="5715000" y="1828800"/>
+            <a:ext cx="3520440" cy="2926080"/>
           </a:xfrm>
           <a:prstGeom prst="ellipse">
             <a:avLst/>
           </a:prstGeom>
           <a:solidFill>
             <a:srgbClr val="FBF0E7">
-              <a:alpha val="95000"/>
+              <a:alpha val="94000"/>
             </a:srgbClr>
           </a:solidFill>
           <a:ln w="25400">
@@ -11621,8 +11919,8 @@
         </p:nvSpPr>
         <p:spPr>
           <a:xfrm>
-            <a:off x="3200400" y="2148840"/>
-            <a:ext cx="2103120" cy="320040"/>
+            <a:off x="3154680" y="2057400"/>
+            <a:ext cx="1828800" cy="310896"/>
           </a:xfrm>
           <a:prstGeom prst="rect">
             <a:avLst/>
@@ -11640,14 +11938,14 @@
               <a:buNone/>
             </a:pPr>
             <a:r>
-              <a:rPr lang="en-US" sz="1500" b="1" dirty="0">
+              <a:rPr lang="en-US" sz="1400" b="1" dirty="0">
                 <a:solidFill>
                   <a:srgbClr val="4EA7C4"/>
                 </a:solidFill>
               </a:rPr>
               <a:t>description</a:t>
             </a:r>
-            <a:endParaRPr lang="en-US" sz="1500" dirty="0"/>
+            <a:endParaRPr lang="en-US" sz="1400" dirty="0"/>
           </a:p>
         </p:txBody>
       </p:sp>
@@ -11659,8 +11957,8 @@
         </p:nvSpPr>
         <p:spPr>
           <a:xfrm>
-            <a:off x="6675120" y="2148840"/>
-            <a:ext cx="1828800" cy="320040"/>
+            <a:off x="6995160" y="2057400"/>
+            <a:ext cx="1645920" cy="310896"/>
           </a:xfrm>
           <a:prstGeom prst="rect">
             <a:avLst/>
@@ -11678,14 +11976,14 @@
               <a:buNone/>
             </a:pPr>
             <a:r>
-              <a:rPr lang="en-US" sz="1500" b="1" dirty="0">
+              <a:rPr lang="en-US" sz="1400" b="1" dirty="0">
                 <a:solidFill>
                   <a:srgbClr val="E58A3B"/>
                 </a:solidFill>
               </a:rPr>
               <a:t>evaluation</a:t>
             </a:r>
-            <a:endParaRPr lang="en-US" sz="1500" dirty="0"/>
+            <a:endParaRPr lang="en-US" sz="1400" dirty="0"/>
           </a:p>
         </p:txBody>
       </p:sp>
@@ -11697,8 +11995,8 @@
         </p:nvSpPr>
         <p:spPr>
           <a:xfrm>
-            <a:off x="4892040" y="2788920"/>
-            <a:ext cx="2423160" cy="713232"/>
+            <a:off x="4800600" y="2743200"/>
+            <a:ext cx="2560320" cy="777240"/>
           </a:xfrm>
           <a:prstGeom prst="rect">
             <a:avLst/>
@@ -11716,14 +12014,14 @@
               <a:buNone/>
             </a:pPr>
             <a:r>
-              <a:rPr lang="en-US" sz="3400" b="1" dirty="0">
+              <a:rPr lang="en-US" sz="3700" b="1" dirty="0">
                 <a:solidFill>
                   <a:srgbClr val="142326"/>
                 </a:solidFill>
               </a:rPr>
               <a:t>CRUEL</a:t>
             </a:r>
-            <a:endParaRPr lang="en-US" sz="3400" dirty="0"/>
+            <a:endParaRPr lang="en-US" sz="3700" dirty="0"/>
           </a:p>
         </p:txBody>
       </p:sp>
@@ -11735,8 +12033,8 @@
         </p:nvSpPr>
         <p:spPr>
           <a:xfrm>
-            <a:off x="2011680" y="4892040"/>
-            <a:ext cx="8138160" cy="566928"/>
+            <a:off x="1828800" y="4937760"/>
+            <a:ext cx="8503920" cy="530352"/>
           </a:xfrm>
           <a:prstGeom prst="rect">
             <a:avLst/>
@@ -11803,7 +12101,7 @@
                   <a:srgbClr val="FFFFFF"/>
                 </a:solidFill>
               </a:rPr>
-              <a:t>A thick concept seems to say what happened and how to assess it.</a:t>
+              <a:t>A thick concept says what happened and how to assess it.</a:t>
             </a:r>
             <a:endParaRPr lang="en-US" sz="1620" dirty="0"/>
           </a:p>
@@ -12051,8 +12349,8 @@
         </p:nvSpPr>
         <p:spPr>
           <a:xfrm>
-            <a:off x="868680" y="2331720"/>
-            <a:ext cx="2011680" cy="822960"/>
+            <a:off x="777240" y="2331720"/>
+            <a:ext cx="1920240" cy="777240"/>
           </a:xfrm>
           <a:prstGeom prst="rect">
             <a:avLst/>
@@ -12076,14 +12374,14 @@
               <a:buNone/>
             </a:pPr>
             <a:r>
-              <a:rPr lang="en-US" sz="2400" b="1" dirty="0">
+              <a:rPr lang="en-US" sz="2300" b="1" dirty="0">
                 <a:solidFill>
                   <a:srgbClr val="142326"/>
                 </a:solidFill>
               </a:rPr>
               <a:t>CRUEL</a:t>
             </a:r>
-            <a:endParaRPr lang="en-US" sz="2400" dirty="0"/>
+            <a:endParaRPr lang="en-US" sz="2300" dirty="0"/>
           </a:p>
         </p:txBody>
       </p:sp>
@@ -12095,14 +12393,14 @@
         </p:nvSpPr>
         <p:spPr>
           <a:xfrm>
-            <a:off x="2971800" y="2743200"/>
-            <a:ext cx="1097280" cy="-594360"/>
+            <a:off x="2788920" y="2651760"/>
+            <a:ext cx="1188720" cy="-594360"/>
           </a:xfrm>
           <a:prstGeom prst="line">
             <a:avLst/>
           </a:prstGeom>
           <a:noFill/>
-          <a:ln w="27940">
+          <a:ln w="26670">
             <a:solidFill>
               <a:srgbClr val="6B7A7C"/>
             </a:solidFill>
@@ -12120,14 +12418,14 @@
         </p:nvSpPr>
         <p:spPr>
           <a:xfrm>
-            <a:off x="2971800" y="2743200"/>
-            <a:ext cx="1097280" cy="1508760"/>
+            <a:off x="2788920" y="2697480"/>
+            <a:ext cx="1188720" cy="1463040"/>
           </a:xfrm>
           <a:prstGeom prst="line">
             <a:avLst/>
           </a:prstGeom>
           <a:noFill/>
-          <a:ln w="27940">
+          <a:ln w="26670">
             <a:solidFill>
               <a:srgbClr val="6B7A7C"/>
             </a:solidFill>
@@ -12145,12 +12443,12 @@
         </p:nvSpPr>
         <p:spPr>
           <a:xfrm>
-            <a:off x="4206240" y="1645920"/>
-            <a:ext cx="6903720" cy="1508760"/>
+            <a:off x="4069080" y="1572768"/>
+            <a:ext cx="7086600" cy="1691640"/>
           </a:xfrm>
           <a:prstGeom prst="roundRect">
             <a:avLst>
-              <a:gd name="adj" fmla="val 4848"/>
+              <a:gd name="adj" fmla="val 4324"/>
             </a:avLst>
           </a:prstGeom>
           <a:solidFill>
@@ -12172,8 +12470,8 @@
         </p:nvSpPr>
         <p:spPr>
           <a:xfrm>
-            <a:off x="4206240" y="1645920"/>
-            <a:ext cx="73152" cy="1508760"/>
+            <a:off x="4069080" y="1572768"/>
+            <a:ext cx="73152" cy="1691640"/>
           </a:xfrm>
           <a:prstGeom prst="rect">
             <a:avLst/>
@@ -12197,8 +12495,8 @@
         </p:nvSpPr>
         <p:spPr>
           <a:xfrm>
-            <a:off x="4462272" y="1847088"/>
-            <a:ext cx="6446520" cy="329184"/>
+            <a:off x="4325112" y="1773936"/>
+            <a:ext cx="6629400" cy="329184"/>
           </a:xfrm>
           <a:prstGeom prst="rect">
             <a:avLst/>
@@ -12235,8 +12533,8 @@
         </p:nvSpPr>
         <p:spPr>
           <a:xfrm>
-            <a:off x="4462272" y="2304288"/>
-            <a:ext cx="6400800" cy="685800"/>
+            <a:off x="4325112" y="2231136"/>
+            <a:ext cx="6583680" cy="868680"/>
           </a:xfrm>
           <a:prstGeom prst="rect">
             <a:avLst/>
@@ -12259,10 +12557,24 @@
                   <a:srgbClr val="304245"/>
                 </a:solidFill>
               </a:rPr>
-              <a:t>hit the prisoner · humiliated him · withheld food · caused pain</a:t>
+              <a:t>hit the prisoner · humiliated him</a:t>
             </a:r>
             <a:endParaRPr lang="en-US" sz="1650" dirty="0"/>
           </a:p>
+          <a:p>
+            <a:pPr indent="0" marL="0">
+              <a:buNone/>
+            </a:pPr>
+            <a:r>
+              <a:rPr lang="en-US" sz="1650" dirty="0">
+                <a:solidFill>
+                  <a:srgbClr val="304245"/>
+                </a:solidFill>
+              </a:rPr>
+              <a:t>withheld food · caused pain</a:t>
+            </a:r>
+            <a:endParaRPr lang="en-US" sz="1650" dirty="0"/>
+          </a:p>
         </p:txBody>
       </p:sp>
       <p:sp>
@@ -12273,12 +12585,12 @@
         </p:nvSpPr>
         <p:spPr>
           <a:xfrm>
-            <a:off x="4206240" y="3794760"/>
-            <a:ext cx="6903720" cy="1508760"/>
+            <a:off x="4069080" y="3657600"/>
+            <a:ext cx="7086600" cy="1691640"/>
           </a:xfrm>
           <a:prstGeom prst="roundRect">
             <a:avLst>
-              <a:gd name="adj" fmla="val 4848"/>
+              <a:gd name="adj" fmla="val 4324"/>
             </a:avLst>
           </a:prstGeom>
           <a:solidFill>
@@ -12300,8 +12612,8 @@
         </p:nvSpPr>
         <p:spPr>
           <a:xfrm>
-            <a:off x="4206240" y="3794760"/>
-            <a:ext cx="73152" cy="1508760"/>
+            <a:off x="4069080" y="3657600"/>
+            <a:ext cx="73152" cy="1691640"/>
           </a:xfrm>
           <a:prstGeom prst="rect">
             <a:avLst/>
@@ -12325,8 +12637,8 @@
         </p:nvSpPr>
         <p:spPr>
           <a:xfrm>
-            <a:off x="4462272" y="3995928"/>
-            <a:ext cx="6446520" cy="329184"/>
+            <a:off x="4325112" y="3858768"/>
+            <a:ext cx="6629400" cy="329184"/>
           </a:xfrm>
           <a:prstGeom prst="rect">
             <a:avLst/>
@@ -12363,8 +12675,8 @@
         </p:nvSpPr>
         <p:spPr>
           <a:xfrm>
-            <a:off x="4462272" y="4453128"/>
-            <a:ext cx="6400800" cy="685800"/>
+            <a:off x="4325112" y="4315968"/>
+            <a:ext cx="6583680" cy="868680"/>
           </a:xfrm>
           <a:prstGeom prst="rect">
             <a:avLst/>
@@ -12387,7 +12699,21 @@
                   <a:srgbClr val="304245"/>
                 </a:solidFill>
               </a:rPr>
-              <a:t>bad · wrong · condemnable · not to be done</a:t>
+              <a:t>bad · wrong · condemnable</a:t>
+            </a:r>
+            <a:endParaRPr lang="en-US" sz="1650" dirty="0"/>
+          </a:p>
+          <a:p>
+            <a:pPr indent="0" marL="0">
+              <a:buNone/>
+            </a:pPr>
+            <a:r>
+              <a:rPr lang="en-US" sz="1650" dirty="0">
+                <a:solidFill>
+                  <a:srgbClr val="304245"/>
+                </a:solidFill>
+              </a:rPr>
+              <a:t>not to be done</a:t>
             </a:r>
             <a:endParaRPr lang="en-US" sz="1650" dirty="0"/>
           </a:p>
@@ -12431,7 +12757,7 @@
                   <a:srgbClr val="FFFFFF"/>
                 </a:solidFill>
               </a:rPr>
-              <a:t>Cruel = D + E ?</a:t>
+              <a:t>Cruel = D + E ?  That is the tempting rescue operation.</a:t>
             </a:r>
             <a:endParaRPr lang="en-US" sz="1620" dirty="0"/>
           </a:p>
@@ -12679,12 +13005,12 @@
         </p:nvSpPr>
         <p:spPr>
           <a:xfrm>
-            <a:off x="731520" y="1874520"/>
-            <a:ext cx="2880360" cy="2926080"/>
+            <a:off x="658368" y="1828800"/>
+            <a:ext cx="2743200" cy="3090672"/>
           </a:xfrm>
           <a:prstGeom prst="roundRect">
             <a:avLst>
-              <a:gd name="adj" fmla="val 2540"/>
+              <a:gd name="adj" fmla="val 2667"/>
             </a:avLst>
           </a:prstGeom>
           <a:solidFill>
@@ -12706,8 +13032,8 @@
         </p:nvSpPr>
         <p:spPr>
           <a:xfrm>
-            <a:off x="731520" y="1874520"/>
-            <a:ext cx="73152" cy="2926080"/>
+            <a:off x="658368" y="1828800"/>
+            <a:ext cx="73152" cy="3090672"/>
           </a:xfrm>
           <a:prstGeom prst="rect">
             <a:avLst/>
@@ -12731,8 +13057,8 @@
         </p:nvSpPr>
         <p:spPr>
           <a:xfrm>
-            <a:off x="987552" y="2075688"/>
-            <a:ext cx="2423160" cy="329184"/>
+            <a:off x="914400" y="2029968"/>
+            <a:ext cx="2286000" cy="329184"/>
           </a:xfrm>
           <a:prstGeom prst="rect">
             <a:avLst/>
@@ -12769,8 +13095,8 @@
         </p:nvSpPr>
         <p:spPr>
           <a:xfrm>
-            <a:off x="987552" y="2532888"/>
-            <a:ext cx="2377440" cy="2103120"/>
+            <a:off x="914400" y="2487168"/>
+            <a:ext cx="2240280" cy="2267712"/>
           </a:xfrm>
           <a:prstGeom prst="rect">
             <a:avLst/>
@@ -12788,56 +13114,56 @@
               <a:buNone/>
             </a:pPr>
             <a:r>
-              <a:rPr lang="en-US" sz="1650" dirty="0">
+              <a:rPr lang="en-US" sz="1580" dirty="0">
                 <a:solidFill>
                   <a:srgbClr val="304245"/>
                 </a:solidFill>
               </a:rPr>
-              <a:t>“caused pain”</a:t>
-            </a:r>
-            <a:endParaRPr lang="en-US" sz="1650" dirty="0"/>
+              <a:t>caused pain</a:t>
+            </a:r>
+            <a:endParaRPr lang="en-US" sz="1580" dirty="0"/>
           </a:p>
           <a:p>
             <a:pPr indent="0" marL="0">
               <a:buNone/>
             </a:pPr>
             <a:r>
-              <a:rPr lang="en-US" sz="1650" dirty="0">
+              <a:rPr lang="en-US" sz="1580" dirty="0">
                 <a:solidFill>
                   <a:srgbClr val="304245"/>
                 </a:solidFill>
               </a:rPr>
-              <a:t>“taught discipline”</a:t>
-            </a:r>
-            <a:endParaRPr lang="en-US" sz="1650" dirty="0"/>
+              <a:t>taught discipline</a:t>
+            </a:r>
+            <a:endParaRPr lang="en-US" sz="1580" dirty="0"/>
           </a:p>
           <a:p>
             <a:pPr indent="0" marL="0">
               <a:buNone/>
             </a:pPr>
             <a:r>
-              <a:rPr lang="en-US" sz="1650" dirty="0">
+              <a:rPr lang="en-US" sz="1580" dirty="0">
                 <a:solidFill>
                   <a:srgbClr val="304245"/>
                 </a:solidFill>
               </a:rPr>
-              <a:t>“humiliated for amusement”</a:t>
-            </a:r>
-            <a:endParaRPr lang="en-US" sz="1650" dirty="0"/>
+              <a:t>humiliated for amusement</a:t>
+            </a:r>
+            <a:endParaRPr lang="en-US" sz="1580" dirty="0"/>
           </a:p>
           <a:p>
             <a:pPr indent="0" marL="0">
               <a:buNone/>
             </a:pPr>
             <a:r>
-              <a:rPr lang="en-US" sz="1650" dirty="0">
+              <a:rPr lang="en-US" sz="1580" dirty="0">
                 <a:solidFill>
                   <a:srgbClr val="304245"/>
                 </a:solidFill>
               </a:rPr>
-              <a:t>“followed policy”</a:t>
-            </a:r>
-            <a:endParaRPr lang="en-US" sz="1650" dirty="0"/>
+              <a:t>followed policy</a:t>
+            </a:r>
+            <a:endParaRPr lang="en-US" sz="1580" dirty="0"/>
           </a:p>
         </p:txBody>
       </p:sp>
@@ -12849,8 +13175,8 @@
         </p:nvSpPr>
         <p:spPr>
           <a:xfrm>
-            <a:off x="4572000" y="2487168"/>
-            <a:ext cx="2926080" cy="1097280"/>
+            <a:off x="4251960" y="2331720"/>
+            <a:ext cx="3063240" cy="1143000"/>
           </a:xfrm>
           <a:prstGeom prst="rect">
             <a:avLst/>
@@ -12874,28 +13200,28 @@
               <a:buNone/>
             </a:pPr>
             <a:r>
-              <a:rPr lang="en-US" sz="1900" b="1" dirty="0">
+              <a:rPr lang="en-US" sz="2000" b="1" dirty="0">
                 <a:solidFill>
                   <a:srgbClr val="087C7E"/>
                 </a:solidFill>
               </a:rPr>
-              <a:t>Which details</a:t>
-            </a:r>
-            <a:endParaRPr lang="en-US" sz="1900" dirty="0"/>
+              <a:t>Which facts</a:t>
+            </a:r>
+            <a:endParaRPr lang="en-US" sz="2000" dirty="0"/>
           </a:p>
           <a:p>
             <a:pPr algn="ctr" indent="0" marL="0">
               <a:buNone/>
             </a:pPr>
             <a:r>
-              <a:rPr lang="en-US" sz="1900" b="1" dirty="0">
+              <a:rPr lang="en-US" sz="2000" b="1" dirty="0">
                 <a:solidFill>
                   <a:srgbClr val="087C7E"/>
                 </a:solidFill>
               </a:rPr>
-              <a:t>matter?</a:t>
-            </a:r>
-            <a:endParaRPr lang="en-US" sz="1900" dirty="0"/>
+              <a:t>are relevant?</a:t>
+            </a:r>
+            <a:endParaRPr lang="en-US" sz="2000" dirty="0"/>
           </a:p>
         </p:txBody>
       </p:sp>
@@ -12907,8 +13233,8 @@
         </p:nvSpPr>
         <p:spPr>
           <a:xfrm>
-            <a:off x="8549640" y="2487168"/>
-            <a:ext cx="2743200" cy="1097280"/>
+            <a:off x="8458200" y="2331720"/>
+            <a:ext cx="2743200" cy="1143000"/>
           </a:xfrm>
           <a:prstGeom prst="rect">
             <a:avLst/>
@@ -12965,8 +13291,8 @@
         </p:nvSpPr>
         <p:spPr>
           <a:xfrm>
-            <a:off x="3657600" y="3017520"/>
-            <a:ext cx="777240" cy="0"/>
+            <a:off x="3520440" y="2907792"/>
+            <a:ext cx="594360" cy="0"/>
           </a:xfrm>
           <a:prstGeom prst="line">
             <a:avLst/>
@@ -12990,8 +13316,8 @@
         </p:nvSpPr>
         <p:spPr>
           <a:xfrm>
-            <a:off x="7543800" y="3017520"/>
-            <a:ext cx="868680" cy="0"/>
+            <a:off x="7452360" y="2907792"/>
+            <a:ext cx="850392" cy="0"/>
           </a:xfrm>
           <a:prstGeom prst="line">
             <a:avLst/>
@@ -13015,14 +13341,14 @@
         </p:nvSpPr>
         <p:spPr>
           <a:xfrm>
-            <a:off x="9921240" y="3749040"/>
-            <a:ext cx="-3017520" cy="868680"/>
+            <a:off x="9829800" y="3767328"/>
+            <a:ext cx="-3840480" cy="804672"/>
           </a:xfrm>
           <a:prstGeom prst="line">
             <a:avLst/>
           </a:prstGeom>
           <a:noFill/>
-          <a:ln w="30480">
+          <a:ln w="27940">
             <a:solidFill>
               <a:srgbClr val="E58A3B"/>
             </a:solidFill>
@@ -13040,8 +13366,8 @@
         </p:nvSpPr>
         <p:spPr>
           <a:xfrm>
-            <a:off x="4572000" y="4160520"/>
-            <a:ext cx="3017520" cy="658368"/>
+            <a:off x="4297680" y="4160520"/>
+            <a:ext cx="3246120" cy="594360"/>
           </a:xfrm>
           <a:prstGeom prst="rect">
             <a:avLst/>
@@ -13059,28 +13385,28 @@
               <a:buNone/>
             </a:pPr>
             <a:r>
-              <a:rPr lang="en-US" sz="1500" b="1" dirty="0">
+              <a:rPr lang="en-US" sz="1450" b="1" dirty="0">
                 <a:solidFill>
                   <a:srgbClr val="304245"/>
                 </a:solidFill>
               </a:rPr>
               <a:t>evaluative understanding guides</a:t>
             </a:r>
-            <a:endParaRPr lang="en-US" sz="1500" dirty="0"/>
+            <a:endParaRPr lang="en-US" sz="1450" dirty="0"/>
           </a:p>
           <a:p>
             <a:pPr algn="ctr" indent="0" marL="0">
               <a:buNone/>
             </a:pPr>
             <a:r>
-              <a:rPr lang="en-US" sz="1500" b="1" dirty="0">
+              <a:rPr lang="en-US" sz="1450" b="1" dirty="0">
                 <a:solidFill>
                   <a:srgbClr val="304245"/>
                 </a:solidFill>
               </a:rPr>
               <a:t>selection and interpretation</a:t>
             </a:r>
-            <a:endParaRPr lang="en-US" sz="1500" dirty="0"/>
+            <a:endParaRPr lang="en-US" sz="1450" dirty="0"/>
           </a:p>
         </p:txBody>
       </p:sp>
@@ -13117,14 +13443,14 @@
               <a:buNone/>
             </a:pPr>
             <a:r>
-              <a:rPr lang="en-US" sz="1620" b="1" dirty="0">
+              <a:rPr lang="en-US" sz="1560" b="1" dirty="0">
                 <a:solidFill>
                   <a:srgbClr val="FFFFFF"/>
                 </a:solidFill>
               </a:rPr>
               <a:t>To recognize the relevant facts as cruelty, you already need the evaluative concept.</a:t>
             </a:r>
-            <a:endParaRPr lang="en-US" sz="1620" dirty="0"/>
+            <a:endParaRPr lang="en-US" sz="1560" dirty="0"/>
           </a:p>
         </p:txBody>
       </p:sp>
@@ -13370,8 +13696,8 @@
         </p:nvSpPr>
         <p:spPr>
           <a:xfrm>
-            <a:off x="1874520" y="5257800"/>
-            <a:ext cx="8138160" cy="0"/>
+            <a:off x="1417320" y="5303520"/>
+            <a:ext cx="8732520" cy="0"/>
           </a:xfrm>
           <a:prstGeom prst="line">
             <a:avLst/>
@@ -13395,8 +13721,8 @@
         </p:nvSpPr>
         <p:spPr>
           <a:xfrm>
-            <a:off x="1874520" y="5257800"/>
-            <a:ext cx="0" cy="-3154680"/>
+            <a:off x="1417320" y="5303520"/>
+            <a:ext cx="0" cy="-3337560"/>
           </a:xfrm>
           <a:prstGeom prst="line">
             <a:avLst/>
@@ -13420,8 +13746,8 @@
         </p:nvSpPr>
         <p:spPr>
           <a:xfrm>
-            <a:off x="9875520" y="5367528"/>
-            <a:ext cx="320040" cy="228600"/>
+            <a:off x="8549640" y="5449824"/>
+            <a:ext cx="1737360" cy="256032"/>
           </a:xfrm>
           <a:prstGeom prst="rect">
             <a:avLst/>
@@ -13439,14 +13765,14 @@
               <a:buNone/>
             </a:pPr>
             <a:r>
-              <a:rPr lang="en-US" sz="1500" b="1" dirty="0">
+              <a:rPr lang="en-US" sz="1200" b="1" dirty="0">
                 <a:solidFill>
                   <a:srgbClr val="6B7A7C"/>
                 </a:solidFill>
               </a:rPr>
-              <a:t>f</a:t>
-            </a:r>
-            <a:endParaRPr lang="en-US" sz="1500" dirty="0"/>
+              <a:t>descriptive content  f</a:t>
+            </a:r>
+            <a:endParaRPr lang="en-US" sz="1200" dirty="0"/>
           </a:p>
         </p:txBody>
       </p:sp>
@@ -13458,8 +13784,8 @@
         </p:nvSpPr>
         <p:spPr>
           <a:xfrm>
-            <a:off x="1554480" y="1938528"/>
-            <a:ext cx="274320" cy="228600"/>
+            <a:off x="1005840" y="1746504"/>
+            <a:ext cx="1828800" cy="256032"/>
           </a:xfrm>
           <a:prstGeom prst="rect">
             <a:avLst/>
@@ -13473,18 +13799,18 @@
           </a:bodyPr>
           <a:lstStyle/>
           <a:p>
-            <a:pPr algn="ctr" indent="0" marL="0">
-              <a:buNone/>
-            </a:pPr>
-            <a:r>
-              <a:rPr lang="en-US" sz="1500" b="1" dirty="0">
+            <a:pPr algn="l" indent="0" marL="0">
+              <a:buNone/>
+            </a:pPr>
+            <a:r>
+              <a:rPr lang="en-US" sz="1200" b="1" dirty="0">
                 <a:solidFill>
                   <a:srgbClr val="6B7A7C"/>
                 </a:solidFill>
               </a:rPr>
-              <a:t>v</a:t>
-            </a:r>
-            <a:endParaRPr lang="en-US" sz="1500" dirty="0"/>
+              <a:t>evaluative content  v</a:t>
+            </a:r>
+            <a:endParaRPr lang="en-US" sz="1200" dirty="0"/>
           </a:p>
         </p:txBody>
       </p:sp>
@@ -13496,7 +13822,7 @@
         </p:nvSpPr>
         <p:spPr>
           <a:xfrm>
-            <a:off x="5961888" y="3081528"/>
+            <a:off x="5916168" y="3054096"/>
             <a:ext cx="329184" cy="329184"/>
           </a:xfrm>
           <a:prstGeom prst="ellipse">
@@ -13521,84 +13847,8 @@
         </p:nvSpPr>
         <p:spPr>
           <a:xfrm>
-            <a:off x="8595360" y="5303520"/>
-            <a:ext cx="2286000" cy="320040"/>
-          </a:xfrm>
-          <a:prstGeom prst="rect">
-            <a:avLst/>
-          </a:prstGeom>
-          <a:noFill/>
-          <a:ln/>
-        </p:spPr>
-        <p:txBody>
-          <a:bodyPr wrap="square" lIns="254" tIns="254" rIns="254" bIns="254" rtlCol="0" anchor="ctr">
-            <a:normAutofit/>
-          </a:bodyPr>
-          <a:lstStyle/>
-          <a:p>
-            <a:pPr algn="ctr" indent="0" marL="0">
-              <a:buNone/>
-            </a:pPr>
-            <a:r>
-              <a:rPr lang="en-US" sz="1400" dirty="0">
-                <a:solidFill>
-                  <a:srgbClr val="6B7A7C"/>
-                </a:solidFill>
-              </a:rPr>
-              <a:t>f = descriptive content</a:t>
-            </a:r>
-            <a:endParaRPr lang="en-US" sz="1400" dirty="0"/>
-          </a:p>
-        </p:txBody>
-      </p:sp>
-      <p:sp>
-        <p:nvSpPr>
-          <p:cNvPr id="14" name="Text 12"/>
-          <p:cNvSpPr/>
-          <p:nvPr/>
-        </p:nvSpPr>
-        <p:spPr>
-          <a:xfrm>
-            <a:off x="685800" y="1874520"/>
-            <a:ext cx="2286000" cy="320040"/>
-          </a:xfrm>
-          <a:prstGeom prst="rect">
-            <a:avLst/>
-          </a:prstGeom>
-          <a:noFill/>
-          <a:ln/>
-        </p:spPr>
-        <p:txBody>
-          <a:bodyPr wrap="square" lIns="254" tIns="254" rIns="254" bIns="254" rtlCol="0" anchor="ctr">
-            <a:normAutofit/>
-          </a:bodyPr>
-          <a:lstStyle/>
-          <a:p>
-            <a:pPr algn="ctr" indent="0" marL="0">
-              <a:buNone/>
-            </a:pPr>
-            <a:r>
-              <a:rPr lang="en-US" sz="1400" dirty="0">
-                <a:solidFill>
-                  <a:srgbClr val="6B7A7C"/>
-                </a:solidFill>
-              </a:rPr>
-              <a:t>v = evaluative content</a:t>
-            </a:r>
-            <a:endParaRPr lang="en-US" sz="1400" dirty="0"/>
-          </a:p>
-        </p:txBody>
-      </p:sp>
-      <p:sp>
-        <p:nvSpPr>
-          <p:cNvPr id="15" name="Text 13"/>
-          <p:cNvSpPr/>
-          <p:nvPr/>
-        </p:nvSpPr>
-        <p:spPr>
-          <a:xfrm>
-            <a:off x="7726680" y="2331720"/>
-            <a:ext cx="2651760" cy="777240"/>
+            <a:off x="8229600" y="1920240"/>
+            <a:ext cx="2331720" cy="713232"/>
           </a:xfrm>
           <a:prstGeom prst="rect">
             <a:avLst/>
@@ -13622,20 +13872,72 @@
               <a:buNone/>
             </a:pPr>
             <a:r>
-              <a:rPr lang="en-US" sz="2200" b="1" dirty="0">
+              <a:rPr lang="en-US" sz="2100" b="1" dirty="0">
                 <a:solidFill>
                   <a:srgbClr val="087C7E"/>
                 </a:solidFill>
               </a:rPr>
               <a:t>J = (f, v)</a:t>
             </a:r>
-            <a:endParaRPr lang="en-US" sz="2200" dirty="0"/>
-          </a:p>
-        </p:txBody>
-      </p:sp>
-      <p:sp>
-        <p:nvSpPr>
-          <p:cNvPr id="16" name="Text 14"/>
+            <a:endParaRPr lang="en-US" sz="2100" dirty="0"/>
+          </a:p>
+        </p:txBody>
+      </p:sp>
+      <p:sp>
+        <p:nvSpPr>
+          <p:cNvPr id="14" name="Text 12"/>
+          <p:cNvSpPr/>
+          <p:nvPr/>
+        </p:nvSpPr>
+        <p:spPr>
+          <a:xfrm>
+            <a:off x="4663440" y="3749040"/>
+            <a:ext cx="2971800" cy="658368"/>
+          </a:xfrm>
+          <a:prstGeom prst="rect">
+            <a:avLst/>
+          </a:prstGeom>
+          <a:noFill/>
+          <a:ln/>
+        </p:spPr>
+        <p:txBody>
+          <a:bodyPr wrap="square" lIns="254" tIns="254" rIns="254" bIns="254" rtlCol="0" anchor="ctr">
+            <a:normAutofit/>
+          </a:bodyPr>
+          <a:lstStyle/>
+          <a:p>
+            <a:pPr algn="ctr" indent="0" marL="0">
+              <a:buNone/>
+            </a:pPr>
+            <a:r>
+              <a:rPr lang="en-US" sz="1400" b="1" dirty="0">
+                <a:solidFill>
+                  <a:srgbClr val="304245"/>
+                </a:solidFill>
+              </a:rPr>
+              <a:t>each judgment has a descriptive</a:t>
+            </a:r>
+            <a:endParaRPr lang="en-US" sz="1400" dirty="0"/>
+          </a:p>
+          <a:p>
+            <a:pPr algn="ctr" indent="0" marL="0">
+              <a:buNone/>
+            </a:pPr>
+            <a:r>
+              <a:rPr lang="en-US" sz="1400" b="1" dirty="0">
+                <a:solidFill>
+                  <a:srgbClr val="304245"/>
+                </a:solidFill>
+              </a:rPr>
+              <a:t>and evaluative coordinate</a:t>
+            </a:r>
+            <a:endParaRPr lang="en-US" sz="1400" dirty="0"/>
+          </a:p>
+        </p:txBody>
+      </p:sp>
+      <p:sp>
+        <p:nvSpPr>
+          <p:cNvPr id="15" name="Text 13"/>
           <p:cNvSpPr/>
           <p:nvPr/>
         </p:nvSpPr>
@@ -13671,7 +13973,7 @@
                   <a:srgbClr val="FFFFFF"/>
                 </a:solidFill>
               </a:rPr>
-              <a:t>A judgment can have both descriptive and evaluative coordinates.</a:t>
+              <a:t>The model lets us avoid the dumb claim that facts and values are simply identical.</a:t>
             </a:r>
             <a:endParaRPr lang="en-US" sz="1620" dirty="0"/>
           </a:p>
@@ -13919,8 +14221,8 @@
         </p:nvSpPr>
         <p:spPr>
           <a:xfrm>
-            <a:off x="1874520" y="5257800"/>
-            <a:ext cx="8138160" cy="0"/>
+            <a:off x="1280160" y="5321808"/>
+            <a:ext cx="9144000" cy="0"/>
           </a:xfrm>
           <a:prstGeom prst="line">
             <a:avLst/>
@@ -13944,8 +14246,8 @@
         </p:nvSpPr>
         <p:spPr>
           <a:xfrm>
-            <a:off x="1874520" y="5257800"/>
-            <a:ext cx="0" cy="-3154680"/>
+            <a:off x="1280160" y="5321808"/>
+            <a:ext cx="0" cy="-3401568"/>
           </a:xfrm>
           <a:prstGeom prst="line">
             <a:avLst/>
@@ -13969,8 +14271,8 @@
         </p:nvSpPr>
         <p:spPr>
           <a:xfrm>
-            <a:off x="9875520" y="5367528"/>
-            <a:ext cx="320040" cy="228600"/>
+            <a:off x="8823960" y="5468112"/>
+            <a:ext cx="1737360" cy="256032"/>
           </a:xfrm>
           <a:prstGeom prst="rect">
             <a:avLst/>
@@ -13988,14 +14290,14 @@
               <a:buNone/>
             </a:pPr>
             <a:r>
-              <a:rPr lang="en-US" sz="1500" b="1" dirty="0">
+              <a:rPr lang="en-US" sz="1200" b="1" dirty="0">
                 <a:solidFill>
                   <a:srgbClr val="6B7A7C"/>
                 </a:solidFill>
               </a:rPr>
-              <a:t>f</a:t>
-            </a:r>
-            <a:endParaRPr lang="en-US" sz="1500" dirty="0"/>
+              <a:t>descriptive content  f</a:t>
+            </a:r>
+            <a:endParaRPr lang="en-US" sz="1200" dirty="0"/>
           </a:p>
         </p:txBody>
       </p:sp>
@@ -14007,8 +14309,8 @@
         </p:nvSpPr>
         <p:spPr>
           <a:xfrm>
-            <a:off x="1554480" y="1938528"/>
-            <a:ext cx="274320" cy="228600"/>
+            <a:off x="868680" y="1700784"/>
+            <a:ext cx="1828800" cy="256032"/>
           </a:xfrm>
           <a:prstGeom prst="rect">
             <a:avLst/>
@@ -14022,18 +14324,18 @@
           </a:bodyPr>
           <a:lstStyle/>
           <a:p>
-            <a:pPr algn="ctr" indent="0" marL="0">
-              <a:buNone/>
-            </a:pPr>
-            <a:r>
-              <a:rPr lang="en-US" sz="1500" b="1" dirty="0">
+            <a:pPr algn="l" indent="0" marL="0">
+              <a:buNone/>
+            </a:pPr>
+            <a:r>
+              <a:rPr lang="en-US" sz="1200" b="1" dirty="0">
                 <a:solidFill>
                   <a:srgbClr val="6B7A7C"/>
                 </a:solidFill>
               </a:rPr>
-              <a:t>v</a:t>
-            </a:r>
-            <a:endParaRPr lang="en-US" sz="1500" dirty="0"/>
+              <a:t>evaluative content  v</a:t>
+            </a:r>
+            <a:endParaRPr lang="en-US" sz="1200" dirty="0"/>
           </a:p>
         </p:txBody>
       </p:sp>
@@ -14045,7 +14347,7 @@
         </p:nvSpPr>
         <p:spPr>
           <a:xfrm>
-            <a:off x="8796528" y="4572000"/>
+            <a:off x="8887968" y="4407408"/>
             <a:ext cx="329184" cy="329184"/>
           </a:xfrm>
           <a:prstGeom prst="ellipse">
@@ -14070,84 +14372,8 @@
         </p:nvSpPr>
         <p:spPr>
           <a:xfrm>
-            <a:off x="6492240" y="3931920"/>
-            <a:ext cx="3474720" cy="457200"/>
-          </a:xfrm>
-          <a:prstGeom prst="rect">
-            <a:avLst/>
-          </a:prstGeom>
-          <a:noFill/>
-          <a:ln/>
-        </p:spPr>
-        <p:txBody>
-          <a:bodyPr wrap="square" lIns="254" tIns="254" rIns="254" bIns="254" rtlCol="0" anchor="ctr">
-            <a:normAutofit/>
-          </a:bodyPr>
-          <a:lstStyle/>
-          <a:p>
-            <a:pPr algn="ctr" indent="0" marL="0">
-              <a:buNone/>
-            </a:pPr>
-            <a:r>
-              <a:rPr lang="en-US" sz="1700" b="1" dirty="0">
-                <a:solidFill>
-                  <a:srgbClr val="304245"/>
-                </a:solidFill>
-              </a:rPr>
-              <a:t>“thermometer reads 22°C”</a:t>
-            </a:r>
-            <a:endParaRPr lang="en-US" sz="1700" dirty="0"/>
-          </a:p>
-        </p:txBody>
-      </p:sp>
-      <p:sp>
-        <p:nvSpPr>
-          <p:cNvPr id="14" name="Text 12"/>
-          <p:cNvSpPr/>
-          <p:nvPr/>
-        </p:nvSpPr>
-        <p:spPr>
-          <a:xfrm>
-            <a:off x="6492240" y="3401568"/>
-            <a:ext cx="3474720" cy="411480"/>
-          </a:xfrm>
-          <a:prstGeom prst="rect">
-            <a:avLst/>
-          </a:prstGeom>
-          <a:noFill/>
-          <a:ln/>
-        </p:spPr>
-        <p:txBody>
-          <a:bodyPr wrap="square" lIns="254" tIns="254" rIns="254" bIns="254" rtlCol="0" anchor="ctr">
-            <a:normAutofit/>
-          </a:bodyPr>
-          <a:lstStyle/>
-          <a:p>
-            <a:pPr algn="ctr" indent="0" marL="0">
-              <a:buNone/>
-            </a:pPr>
-            <a:r>
-              <a:rPr lang="en-US" sz="1500" dirty="0">
-                <a:solidFill>
-                  <a:srgbClr val="6B7A7C"/>
-                </a:solidFill>
-              </a:rPr>
-              <a:t>“water boils at sea level”</a:t>
-            </a:r>
-            <a:endParaRPr lang="en-US" sz="1500" dirty="0"/>
-          </a:p>
-        </p:txBody>
-      </p:sp>
-      <p:sp>
-        <p:nvSpPr>
-          <p:cNvPr id="15" name="Text 13"/>
-          <p:cNvSpPr/>
-          <p:nvPr/>
-        </p:nvSpPr>
-        <p:spPr>
-          <a:xfrm>
-            <a:off x="3977640" y="2331720"/>
-            <a:ext cx="2926080" cy="749808"/>
+            <a:off x="4023360" y="1938528"/>
+            <a:ext cx="3017520" cy="658368"/>
           </a:xfrm>
           <a:prstGeom prst="rect">
             <a:avLst/>
@@ -14184,7 +14410,135 @@
       </p:sp>
       <p:sp>
         <p:nvSpPr>
+          <p:cNvPr id="14" name="Shape 12"/>
+          <p:cNvSpPr/>
+          <p:nvPr/>
+        </p:nvSpPr>
+        <p:spPr>
+          <a:xfrm>
+            <a:off x="7315200" y="2971800"/>
+            <a:ext cx="3154680" cy="1097280"/>
+          </a:xfrm>
+          <a:prstGeom prst="roundRect">
+            <a:avLst>
+              <a:gd name="adj" fmla="val 6667"/>
+            </a:avLst>
+          </a:prstGeom>
+          <a:solidFill>
+            <a:srgbClr val="EAF3F7"/>
+          </a:solidFill>
+          <a:ln w="13970">
+            <a:solidFill>
+              <a:srgbClr val="D8E2E0"/>
+            </a:solidFill>
+            <a:prstDash val="solid"/>
+          </a:ln>
+        </p:spPr>
+      </p:sp>
+      <p:sp>
+        <p:nvSpPr>
+          <p:cNvPr id="15" name="Shape 13"/>
+          <p:cNvSpPr/>
+          <p:nvPr/>
+        </p:nvSpPr>
+        <p:spPr>
+          <a:xfrm>
+            <a:off x="7315200" y="2971800"/>
+            <a:ext cx="73152" cy="1097280"/>
+          </a:xfrm>
+          <a:prstGeom prst="rect">
+            <a:avLst/>
+          </a:prstGeom>
+          <a:solidFill>
+            <a:srgbClr val="4EA7C4"/>
+          </a:solidFill>
+          <a:ln w="12700">
+            <a:solidFill>
+              <a:srgbClr val="4EA7C4"/>
+            </a:solidFill>
+            <a:prstDash val="solid"/>
+          </a:ln>
+        </p:spPr>
+      </p:sp>
+      <p:sp>
+        <p:nvSpPr>
           <p:cNvPr id="16" name="Text 14"/>
+          <p:cNvSpPr/>
+          <p:nvPr/>
+        </p:nvSpPr>
+        <p:spPr>
+          <a:xfrm>
+            <a:off x="7571232" y="3172968"/>
+            <a:ext cx="2697480" cy="329184"/>
+          </a:xfrm>
+          <a:prstGeom prst="rect">
+            <a:avLst/>
+          </a:prstGeom>
+          <a:noFill/>
+          <a:ln/>
+        </p:spPr>
+        <p:txBody>
+          <a:bodyPr wrap="square" lIns="0" tIns="0" rIns="0" bIns="0" rtlCol="0" anchor="ctr">
+            <a:normAutofit/>
+          </a:bodyPr>
+          <a:lstStyle/>
+          <a:p>
+            <a:pPr indent="0" marL="0">
+              <a:buNone/>
+            </a:pPr>
+            <a:r>
+              <a:rPr lang="en-US" sz="1500" b="1" dirty="0">
+                <a:solidFill>
+                  <a:srgbClr val="4EA7C4"/>
+                </a:solidFill>
+              </a:rPr>
+              <a:t>EXAMPLE</a:t>
+            </a:r>
+            <a:endParaRPr lang="en-US" sz="1500" dirty="0"/>
+          </a:p>
+        </p:txBody>
+      </p:sp>
+      <p:sp>
+        <p:nvSpPr>
+          <p:cNvPr id="17" name="Text 15"/>
+          <p:cNvSpPr/>
+          <p:nvPr/>
+        </p:nvSpPr>
+        <p:spPr>
+          <a:xfrm>
+            <a:off x="7571232" y="3630168"/>
+            <a:ext cx="2651760" cy="274320"/>
+          </a:xfrm>
+          <a:prstGeom prst="rect">
+            <a:avLst/>
+          </a:prstGeom>
+          <a:noFill/>
+          <a:ln/>
+        </p:spPr>
+        <p:txBody>
+          <a:bodyPr wrap="square" lIns="254" tIns="254" rIns="254" bIns="254" rtlCol="0" anchor="ctr">
+            <a:normAutofit/>
+          </a:bodyPr>
+          <a:lstStyle/>
+          <a:p>
+            <a:pPr indent="0" marL="0">
+              <a:buNone/>
+            </a:pPr>
+            <a:r>
+              <a:rPr lang="en-US" sz="1500" dirty="0">
+                <a:solidFill>
+                  <a:srgbClr val="304245"/>
+                </a:solidFill>
+              </a:rPr>
+              <a:t>“The thermometer reads 22°C.”</a:t>
+            </a:r>
+            <a:endParaRPr lang="en-US" sz="1500" dirty="0"/>
+          </a:p>
+        </p:txBody>
+      </p:sp>
+      <p:sp>
+        <p:nvSpPr>
+          <p:cNvPr id="18" name="Text 16"/>
           <p:cNvSpPr/>
           <p:nvPr/>
         </p:nvSpPr>
@@ -14220,7 +14574,7 @@
                   <a:srgbClr val="FFFFFF"/>
                 </a:solidFill>
               </a:rPr>
-              <a:t>Close to the descriptive axis does not mean literally value-free.</a:t>
+              <a:t>Close to the descriptive axis does not mean metaphysically value-free.</a:t>
             </a:r>
             <a:endParaRPr lang="en-US" sz="1620" dirty="0"/>
           </a:p>

</xml_diff>